<commit_message>
Strictly align defense presentation with user outline: Problem Study, Research Gap (cited), Objectives, Methodology (diagram), Dataset & Augmentation (sample grid), Model & Triplet Attention (module diagram), Training Strategy (curves), Results & Metrics (confusion matrix & F1), Mobile App Integration (screenshots), Grad-CAM Heatmaps (maximized grid), Conclusion & Recommendations, and References
</commit_message>
<xml_diff>
--- a/Power Point Templete.pptx
+++ b/Power Point Templete.pptx
@@ -5521,6 +5521,81 @@
           </a:p>
         </p:txBody>
       </p:sp>
+      <p:sp>
+        <p:nvSpPr>
+          <p:cNvPr id="20" name="TextBox 19"/>
+          <p:cNvSpPr txBox="1"/>
+          <p:nvPr/>
+        </p:nvSpPr>
+        <p:spPr>
+          <a:xfrm>
+            <a:off x="859536" y="4297680"/>
+            <a:ext cx="7434072" cy="1005840"/>
+          </a:xfrm>
+          <a:prstGeom prst="rect">
+            <a:avLst/>
+          </a:prstGeom>
+          <a:noFill/>
+        </p:spPr>
+        <p:txBody>
+          <a:bodyPr wrap="square">
+            <a:spAutoFit/>
+          </a:bodyPr>
+          <a:lstStyle/>
+          <a:p>
+            <a:pPr algn="ctr">
+              <a:defRPr sz="1000" b="1">
+                <a:solidFill>
+                  <a:srgbClr val="154360"/>
+                </a:solidFill>
+                <a:latin typeface="Calibri"/>
+              </a:defRPr>
+            </a:pPr>
+            <a:r>
+              <a:t>PROJECT TEAM (PRESENTERS):</a:t>
+            </a:r>
+          </a:p>
+          <a:p>
+            <a:pPr algn="ctr">
+              <a:defRPr sz="950" b="1">
+                <a:solidFill>
+                  <a:srgbClr val="2C3E50"/>
+                </a:solidFill>
+                <a:latin typeface="Calibri"/>
+              </a:defRPr>
+            </a:pPr>
+            <a:r>
+              <a:t>Ntiamoah Prince Agyei (STUBTECH220135)  |  Adjei Sarfo Joseph (STUBTECH221244)</a:t>
+            </a:r>
+          </a:p>
+          <a:p>
+            <a:pPr algn="ctr">
+              <a:defRPr sz="950" b="1">
+                <a:solidFill>
+                  <a:srgbClr val="2C3E50"/>
+                </a:solidFill>
+                <a:latin typeface="Calibri"/>
+              </a:defRPr>
+            </a:pPr>
+            <a:r>
+              <a:t>Abdul Wasiu Abubakr (STUBTECH220035)  |  Lomotey Nathaniel Julian (STUBTECH220073)</a:t>
+            </a:r>
+          </a:p>
+          <a:p>
+            <a:pPr algn="ctr">
+              <a:defRPr sz="950" i="1">
+                <a:solidFill>
+                  <a:srgbClr val="186A3B"/>
+                </a:solidFill>
+                <a:latin typeface="Calibri"/>
+              </a:defRPr>
+            </a:pPr>
+            <a:r>
+              <a:t>Supervisors: Mr. Buabeng Solomon &amp; Mrs. Awuti Mensah</a:t>
+            </a:r>
+          </a:p>
+        </p:txBody>
+      </p:sp>
     </p:spTree>
     <p:extLst>
       <p:ext uri="{BB962C8B-B14F-4D97-AF65-F5344CB8AC3E}">
@@ -5598,7 +5673,7 @@
               </a:defRPr>
             </a:pPr>
             <a:r>
-              <a:t>Triplet Attention Module Architectural Diagram</a:t>
+              <a:t>Triplet Attention Module Architecture Diagram</a:t>
             </a:r>
             <a:endParaRPr lang="en-GH" dirty="0"/>
           </a:p>
@@ -5890,6 +5965,30 @@
           </a:prstGeom>
         </p:spPr>
       </p:pic>
+      <p:pic>
+        <p:nvPicPr>
+          <p:cNvPr id="12" name="Picture 11" descr="image.png"/>
+          <p:cNvPicPr>
+            <a:picLocks noChangeAspect="1"/>
+          </p:cNvPicPr>
+          <p:nvPr/>
+        </p:nvPicPr>
+        <p:blipFill>
+          <a:blip r:embed="rId3"/>
+          <a:stretch>
+            <a:fillRect/>
+          </a:stretch>
+        </p:blipFill>
+        <p:spPr>
+          <a:xfrm>
+            <a:off x="777240" y="1005840"/>
+            <a:ext cx="7589520" cy="5029200"/>
+          </a:xfrm>
+          <a:prstGeom prst="rect">
+            <a:avLst/>
+          </a:prstGeom>
+        </p:spPr>
+      </p:pic>
     </p:spTree>
     <p:extLst>
       <p:ext uri="{BB962C8B-B14F-4D97-AF65-F5344CB8AC3E}">
@@ -5937,7 +6036,7 @@
               </a:defRPr>
             </a:pPr>
             <a:r>
-              <a:t>Two-Phase Transfer Learning &amp; Optimization</a:t>
+              <a:t>Training Strategy</a:t>
             </a:r>
           </a:p>
         </p:txBody>
@@ -6046,11 +6145,11 @@
             <a:r>
               <a:rPr sz="1150" i="1">
                 <a:solidFill>
-                  <a:srgbClr val="D48F00"/>
-                </a:solidFill>
-                <a:latin typeface="Calibri"/>
-              </a:rPr>
-              <a:t> [Szegedy et al., 2016]</a:t>
+                  <a:srgbClr val="B46E00"/>
+                </a:solidFill>
+                <a:latin typeface="Calibri"/>
+              </a:rPr>
+              <a:t> (Szegedy et al., 2016)</a:t>
             </a:r>
           </a:p>
           <a:p>
@@ -6083,11 +6182,11 @@
             <a:r>
               <a:rPr sz="1150" i="1">
                 <a:solidFill>
-                  <a:srgbClr val="D48F00"/>
-                </a:solidFill>
-                <a:latin typeface="Calibri"/>
-              </a:rPr>
-              <a:t> [Kingma &amp; Ba, 2014]</a:t>
+                  <a:srgbClr val="B46E00"/>
+                </a:solidFill>
+                <a:latin typeface="Calibri"/>
+              </a:rPr>
+              <a:t> (Kingma &amp; Ba, 2014)</a:t>
             </a:r>
           </a:p>
           <a:p>
@@ -6115,7 +6214,7 @@
                 </a:solidFill>
                 <a:latin typeface="Calibri"/>
               </a:rPr>
-              <a:t>Early stopping (patience=7 on val_loss) and ReduceLROnPlateau (factor=0.2, patience=3) ensure optimal generalization.</a:t>
+              <a:t>Early stopping (patience=7 on val_loss) and ReduceLROnPlateau (factor=0.2, patience=3) guarantee robust generalization.</a:t>
             </a:r>
           </a:p>
         </p:txBody>
@@ -6270,6 +6369,30 @@
           </a:prstGeom>
         </p:spPr>
       </p:pic>
+      <p:pic>
+        <p:nvPicPr>
+          <p:cNvPr id="6" name="Picture 5" descr="image.png"/>
+          <p:cNvPicPr>
+            <a:picLocks noChangeAspect="1"/>
+          </p:cNvPicPr>
+          <p:nvPr/>
+        </p:nvPicPr>
+        <p:blipFill>
+          <a:blip r:embed="rId3"/>
+          <a:stretch>
+            <a:fillRect/>
+          </a:stretch>
+        </p:blipFill>
+        <p:spPr>
+          <a:xfrm>
+            <a:off x="1005840" y="1051560"/>
+            <a:ext cx="7132320" cy="4937760"/>
+          </a:xfrm>
+          <a:prstGeom prst="rect">
+            <a:avLst/>
+          </a:prstGeom>
+        </p:spPr>
+      </p:pic>
     </p:spTree>
   </p:cSld>
   <p:clrMapOvr>
@@ -6312,7 +6435,7 @@
               </a:defRPr>
             </a:pPr>
             <a:r>
-              <a:t>Results, Metrics &amp; State-of-the-Art Benchmark</a:t>
+              <a:t>Results and Metrics</a:t>
             </a:r>
           </a:p>
         </p:txBody>
@@ -6347,7 +6470,7 @@
                 </a:solidFill>
                 <a:latin typeface="Calibri"/>
               </a:rPr>
-              <a:t>Classification Accuracy: </a:t>
+              <a:t>Test Classification Accuracy: </a:t>
             </a:r>
             <a:r>
               <a:rPr sz="1300">
@@ -6375,7 +6498,7 @@
                 </a:solidFill>
                 <a:latin typeface="Calibri"/>
               </a:rPr>
-              <a:t>Balanced F1 Performance: </a:t>
+              <a:t>Balanced F1-Scores: </a:t>
             </a:r>
             <a:r>
               <a:rPr sz="1300">
@@ -6431,7 +6554,7 @@
                 </a:solidFill>
                 <a:latin typeface="Calibri"/>
               </a:rPr>
-              <a:t>Extreme Edge Compression: </a:t>
+              <a:t>Extreme Edge Footprint: </a:t>
             </a:r>
             <a:r>
               <a:rPr sz="1300">
@@ -6440,7 +6563,7 @@
                 </a:solidFill>
                 <a:latin typeface="Calibri"/>
               </a:rPr>
-              <a:t>5.1 MB INT8 TFLite model footprint (74.9% storage reduction from 20.3 MB FP32 Keras).</a:t>
+              <a:t>5.1 MB INT8 TFLite model size (74.9% storage reduction from 20.3 MB FP32 Keras).</a:t>
             </a:r>
           </a:p>
           <a:p>
@@ -6473,11 +6596,11 @@
             <a:r>
               <a:rPr sz="1100" i="1">
                 <a:solidFill>
-                  <a:srgbClr val="D48F00"/>
-                </a:solidFill>
-                <a:latin typeface="Calibri"/>
-              </a:rPr>
-              <a:t> [Mohanty et al., 2016; Too et al., 2019; Agarwal et al., 2021]</a:t>
+                  <a:srgbClr val="B46E00"/>
+                </a:solidFill>
+                <a:latin typeface="Calibri"/>
+              </a:rPr>
+              <a:t> (Mohanty et al., 2016; Too et al., 2019; Agarwal et al., 2021)</a:t>
             </a:r>
           </a:p>
         </p:txBody>
@@ -6607,6 +6730,54 @@
           </a:prstGeom>
         </p:spPr>
       </p:pic>
+      <p:pic>
+        <p:nvPicPr>
+          <p:cNvPr id="6" name="Picture 5" descr="image.png"/>
+          <p:cNvPicPr>
+            <a:picLocks noChangeAspect="1"/>
+          </p:cNvPicPr>
+          <p:nvPr/>
+        </p:nvPicPr>
+        <p:blipFill>
+          <a:blip r:embed="rId2"/>
+          <a:stretch>
+            <a:fillRect/>
+          </a:stretch>
+        </p:blipFill>
+        <p:spPr>
+          <a:xfrm>
+            <a:off x="594360" y="1097280"/>
+            <a:ext cx="3886200" cy="4754880"/>
+          </a:xfrm>
+          <a:prstGeom prst="rect">
+            <a:avLst/>
+          </a:prstGeom>
+        </p:spPr>
+      </p:pic>
+      <p:pic>
+        <p:nvPicPr>
+          <p:cNvPr id="7" name="Picture 6" descr="image.png"/>
+          <p:cNvPicPr>
+            <a:picLocks noChangeAspect="1"/>
+          </p:cNvPicPr>
+          <p:nvPr/>
+        </p:nvPicPr>
+        <p:blipFill>
+          <a:blip r:embed="rId3"/>
+          <a:stretch>
+            <a:fillRect/>
+          </a:stretch>
+        </p:blipFill>
+        <p:spPr>
+          <a:xfrm>
+            <a:off x="4663440" y="1234440"/>
+            <a:ext cx="3931920" cy="4572000"/>
+          </a:xfrm>
+          <a:prstGeom prst="rect">
+            <a:avLst/>
+          </a:prstGeom>
+        </p:spPr>
+      </p:pic>
     </p:spTree>
   </p:cSld>
   <p:clrMapOvr>
@@ -6649,7 +6820,7 @@
               </a:defRPr>
             </a:pPr>
             <a:r>
-              <a:t>Mobile Application Architecture &amp; Integration</a:t>
+              <a:t>Mobile App Integration</a:t>
             </a:r>
           </a:p>
         </p:txBody>
@@ -6684,7 +6855,7 @@
                 </a:solidFill>
                 <a:latin typeface="Calibri"/>
               </a:rPr>
-              <a:t>Cross-Platform Flutter Engine: </a:t>
+              <a:t>Cross-Platform Flutter Architecture: </a:t>
             </a:r>
             <a:r>
               <a:rPr sz="1300">
@@ -6693,16 +6864,16 @@
                 </a:solidFill>
                 <a:latin typeface="Calibri"/>
               </a:rPr>
-              <a:t>Native compilation to Android ARM64 binaries for smooth 60 FPS user interface performance.</a:t>
+              <a:t>Native compilation to Android ARM64 binaries for smooth 60 FPS user experience.</a:t>
             </a:r>
             <a:r>
               <a:rPr sz="1150" i="1">
                 <a:solidFill>
-                  <a:srgbClr val="D48F00"/>
-                </a:solidFill>
-                <a:latin typeface="Calibri"/>
-              </a:rPr>
-              <a:t> [Sarker et al., 2024]</a:t>
+                  <a:srgbClr val="B46E00"/>
+                </a:solidFill>
+                <a:latin typeface="Calibri"/>
+              </a:rPr>
+              <a:t> (Sarker et al., 2024)</a:t>
             </a:r>
           </a:p>
           <a:p>
@@ -6730,7 +6901,7 @@
                 </a:solidFill>
                 <a:latin typeface="Calibri"/>
               </a:rPr>
-              <a:t>Interactive camera interface with leaf framing overlay, auto-resizing (224x224), and normalization.</a:t>
+              <a:t>Interactive camera interface with leaf framing guide, auto-resizing (224x224), and normalization.</a:t>
             </a:r>
           </a:p>
           <a:p>
@@ -6814,7 +6985,7 @@
                 </a:solidFill>
                 <a:latin typeface="Calibri"/>
               </a:rPr>
-              <a:t>Persists past scans, disease severity, timestamps, and GPS coordinates for field tracking.</a:t>
+              <a:t>Persists past scans, disease severity, timestamps, and GPS coordinates for farm health monitoring.</a:t>
             </a:r>
           </a:p>
         </p:txBody>
@@ -6968,6 +7139,78 @@
           </a:prstGeom>
         </p:spPr>
       </p:pic>
+      <p:pic>
+        <p:nvPicPr>
+          <p:cNvPr id="7" name="Picture 6" descr="image.png"/>
+          <p:cNvPicPr>
+            <a:picLocks noChangeAspect="1"/>
+          </p:cNvPicPr>
+          <p:nvPr/>
+        </p:nvPicPr>
+        <p:blipFill>
+          <a:blip r:embed="rId2"/>
+          <a:stretch>
+            <a:fillRect/>
+          </a:stretch>
+        </p:blipFill>
+        <p:spPr>
+          <a:xfrm>
+            <a:off x="594360" y="1051560"/>
+            <a:ext cx="2560320" cy="3436346"/>
+          </a:xfrm>
+          <a:prstGeom prst="rect">
+            <a:avLst/>
+          </a:prstGeom>
+        </p:spPr>
+      </p:pic>
+      <p:pic>
+        <p:nvPicPr>
+          <p:cNvPr id="8" name="Picture 7" descr="image.png"/>
+          <p:cNvPicPr>
+            <a:picLocks noChangeAspect="1"/>
+          </p:cNvPicPr>
+          <p:nvPr/>
+        </p:nvPicPr>
+        <p:blipFill>
+          <a:blip r:embed="rId3"/>
+          <a:stretch>
+            <a:fillRect/>
+          </a:stretch>
+        </p:blipFill>
+        <p:spPr>
+          <a:xfrm>
+            <a:off x="3291840" y="1051560"/>
+            <a:ext cx="2560320" cy="5090955"/>
+          </a:xfrm>
+          <a:prstGeom prst="rect">
+            <a:avLst/>
+          </a:prstGeom>
+        </p:spPr>
+      </p:pic>
+      <p:pic>
+        <p:nvPicPr>
+          <p:cNvPr id="9" name="Picture 8" descr="image.png"/>
+          <p:cNvPicPr>
+            <a:picLocks noChangeAspect="1"/>
+          </p:cNvPicPr>
+          <p:nvPr/>
+        </p:nvPicPr>
+        <p:blipFill>
+          <a:blip r:embed="rId4"/>
+          <a:stretch>
+            <a:fillRect/>
+          </a:stretch>
+        </p:blipFill>
+        <p:spPr>
+          <a:xfrm>
+            <a:off x="5989320" y="1051560"/>
+            <a:ext cx="2560320" cy="5127934"/>
+          </a:xfrm>
+          <a:prstGeom prst="rect">
+            <a:avLst/>
+          </a:prstGeom>
+        </p:spPr>
+      </p:pic>
     </p:spTree>
   </p:cSld>
   <p:clrMapOvr>
@@ -7010,7 +7253,7 @@
               </a:defRPr>
             </a:pPr>
             <a:r>
-              <a:t>Explainable AI (XAI) via Grad-CAM Heatmaps</a:t>
+              <a:t>Grad-CAM Heatmaps</a:t>
             </a:r>
           </a:p>
         </p:txBody>
@@ -7059,11 +7302,11 @@
             <a:r>
               <a:rPr sz="1150" i="1">
                 <a:solidFill>
-                  <a:srgbClr val="D48F00"/>
-                </a:solidFill>
-                <a:latin typeface="Calibri"/>
-              </a:rPr>
-              <a:t> [Selvaraju et al., 2017]</a:t>
+                  <a:srgbClr val="B46E00"/>
+                </a:solidFill>
+                <a:latin typeface="Calibri"/>
+              </a:rPr>
+              <a:t> (Selvaraju et al., 2017)</a:t>
             </a:r>
           </a:p>
           <a:p>
@@ -7092,6 +7335,15 @@
                 <a:latin typeface="Calibri"/>
               </a:rPr>
               <a:t>Essential visual verification guide for farmers and agricultural extension officers:</a:t>
+            </a:r>
+            <a:r>
+              <a:rPr sz="1150" i="1">
+                <a:solidFill>
+                  <a:srgbClr val="B46E00"/>
+                </a:solidFill>
+                <a:latin typeface="Calibri"/>
+              </a:rPr>
+              <a:t> (Rahman et al., 2024; Vyas et al., 2023)</a:t>
             </a:r>
           </a:p>
           <a:p>
@@ -7250,7 +7502,7 @@
               </a:defRPr>
             </a:pPr>
             <a:r>
-              <a:t>Grad-CAM Feature Attention Heatmaps Across Classes</a:t>
+              <a:t>Grad-CAM Feature Attention Heatmaps Across Disease Classes</a:t>
             </a:r>
           </a:p>
         </p:txBody>
@@ -7279,6 +7531,30 @@
       <p:pic>
         <p:nvPicPr>
           <p:cNvPr id="4" name="Picture 3" descr="image.png"/>
+          <p:cNvPicPr>
+            <a:picLocks noChangeAspect="1"/>
+          </p:cNvPicPr>
+          <p:nvPr/>
+        </p:nvPicPr>
+        <p:blipFill>
+          <a:blip r:embed="rId2"/>
+          <a:stretch>
+            <a:fillRect/>
+          </a:stretch>
+        </p:blipFill>
+        <p:spPr>
+          <a:xfrm>
+            <a:off x="777240" y="1005840"/>
+            <a:ext cx="7589520" cy="5029200"/>
+          </a:xfrm>
+          <a:prstGeom prst="rect">
+            <a:avLst/>
+          </a:prstGeom>
+        </p:spPr>
+      </p:pic>
+      <p:pic>
+        <p:nvPicPr>
+          <p:cNvPr id="5" name="Picture 4" descr="image.png"/>
           <p:cNvPicPr>
             <a:picLocks noChangeAspect="1"/>
           </p:cNvPicPr>
@@ -7342,7 +7618,7 @@
               </a:defRPr>
             </a:pPr>
             <a:r>
-              <a:t>Conclusion &amp; Recommendations for Future Work</a:t>
+              <a:t>Conclusion and Recommendation</a:t>
             </a:r>
           </a:p>
         </p:txBody>
@@ -7433,7 +7709,7 @@
                 </a:solidFill>
                 <a:latin typeface="Calibri"/>
               </a:rPr>
-              <a:t>Empirical Validation: </a:t>
+              <a:t>Empirical Usability Validation: </a:t>
             </a:r>
             <a:r>
               <a:rPr sz="1300">
@@ -7447,11 +7723,11 @@
             <a:r>
               <a:rPr sz="1150" i="1">
                 <a:solidFill>
-                  <a:srgbClr val="D48F00"/>
-                </a:solidFill>
-                <a:latin typeface="Calibri"/>
-              </a:rPr>
-              <a:t> [Brooke, 1996; Bangor et al., 2008]</a:t>
+                  <a:srgbClr val="B46E00"/>
+                </a:solidFill>
+                <a:latin typeface="Calibri"/>
+              </a:rPr>
+              <a:t> (Brooke, 1996; Bangor et al., 2008)</a:t>
             </a:r>
           </a:p>
           <a:p>
@@ -7637,7 +7913,7 @@
                 </a:solidFill>
                 <a:latin typeface="Calibri"/>
               </a:rPr>
-              <a:t>Economic Pillar: </a:t>
+              <a:t>Economic Importance: </a:t>
             </a:r>
             <a:r>
               <a:rPr sz="1350">
@@ -7668,7 +7944,7 @@
                 </a:solidFill>
                 <a:latin typeface="Calibri"/>
               </a:rPr>
-              <a:t>Vulnerable Staple Crops: </a:t>
+              <a:t>Staple Crop Vulnerability: </a:t>
             </a:r>
             <a:r>
               <a:rPr sz="1350">
@@ -7677,7 +7953,16 @@
                 </a:solidFill>
                 <a:latin typeface="Calibri"/>
               </a:rPr>
-              <a:t>Tomato (Solanum lycopersicum) and Maize (Zea mays) suffer from destructive fungal, bacterial, and viral pathogens.</a:t>
+              <a:t>Tomato and Maize face destructive fungal, bacterial, and viral pathogens, causing 30% to 80% annual harvest losses.</a:t>
+            </a:r>
+            <a:r>
+              <a:rPr sz="1200" i="1">
+                <a:solidFill>
+                  <a:srgbClr val="B46E00"/>
+                </a:solidFill>
+                <a:latin typeface="Calibri"/>
+              </a:rPr>
+              <a:t> (Shrivastava et al., 2023)</a:t>
             </a:r>
           </a:p>
           <a:p>
@@ -7696,7 +7981,7 @@
                 </a:solidFill>
                 <a:latin typeface="Calibri"/>
               </a:rPr>
-              <a:t>Devastating Harvest Losses: </a:t>
+              <a:t>Severe Extension Shortage: </a:t>
             </a:r>
             <a:r>
               <a:rPr sz="1350">
@@ -7705,16 +7990,16 @@
                 </a:solidFill>
                 <a:latin typeface="Calibri"/>
               </a:rPr>
-              <a:t>Pathologies such as Early/Late Blight and Common Rust cause 30% to 80% annual yield reductions.</a:t>
+              <a:t>Developing farming districts average only 1 agricultural extension officer per 1,500+ smallholder farmers.</a:t>
             </a:r>
             <a:r>
               <a:rPr sz="1200" i="1">
                 <a:solidFill>
-                  <a:srgbClr val="D48F00"/>
-                </a:solidFill>
-                <a:latin typeface="Calibri"/>
-              </a:rPr>
-              <a:t> [FAO, 2023]</a:t>
+                  <a:srgbClr val="B46E00"/>
+                </a:solidFill>
+                <a:latin typeface="Calibri"/>
+              </a:rPr>
+              <a:t> (Danquah et al., 2024)</a:t>
             </a:r>
           </a:p>
           <a:p>
@@ -7733,7 +8018,7 @@
                 </a:solidFill>
                 <a:latin typeface="Calibri"/>
               </a:rPr>
-              <a:t>Severe Extension Deficit: </a:t>
+              <a:t>Diagnostic Misclassification: </a:t>
             </a:r>
             <a:r>
               <a:rPr sz="1350">
@@ -7742,16 +8027,16 @@
                 </a:solidFill>
                 <a:latin typeface="Calibri"/>
               </a:rPr>
-              <a:t>Developing regions average 1 agricultural extension officer per 1,500+ smallholder farmers.</a:t>
+              <a:t>Visual symptom overlap between blights and leaf spots leads to improper agrochemical application and crop damage.</a:t>
             </a:r>
             <a:r>
               <a:rPr sz="1200" i="1">
                 <a:solidFill>
-                  <a:srgbClr val="D48F00"/>
-                </a:solidFill>
-                <a:latin typeface="Calibri"/>
-              </a:rPr>
-              <a:t> [MoFA Ghana, 2022]</a:t>
+                  <a:srgbClr val="B46E00"/>
+                </a:solidFill>
+                <a:latin typeface="Calibri"/>
+              </a:rPr>
+              <a:t> (Okafor &amp; Appiah, 2024)</a:t>
             </a:r>
           </a:p>
           <a:p>
@@ -7770,35 +8055,7 @@
                 </a:solidFill>
                 <a:latin typeface="Calibri"/>
               </a:rPr>
-              <a:t>Diagnostic Misclassification: </a:t>
-            </a:r>
-            <a:r>
-              <a:rPr sz="1350">
-                <a:solidFill>
-                  <a:srgbClr val="2C3E50"/>
-                </a:solidFill>
-                <a:latin typeface="Calibri"/>
-              </a:rPr>
-              <a:t>Visual symptoms overlap significantly, leading to improper agrochemical use and environmental toxicity.</a:t>
-            </a:r>
-          </a:p>
-          <a:p>
-            <a:pPr>
-              <a:spcBef>
-                <a:spcPts val="200"/>
-              </a:spcBef>
-              <a:spcAft>
-                <a:spcPts val="500"/>
-              </a:spcAft>
-            </a:pPr>
-            <a:r>
-              <a:rPr b="1" sz="1350">
-                <a:solidFill>
-                  <a:srgbClr val="154360"/>
-                </a:solidFill>
-                <a:latin typeface="Calibri"/>
-              </a:rPr>
-              <a:t>Urgent Project Imperative: </a:t>
+              <a:t>The Core Need: </a:t>
             </a:r>
             <a:r>
               <a:rPr sz="1350">
@@ -8006,7 +8263,7 @@
                 </a:solidFill>
                 <a:latin typeface="Calibri"/>
               </a:rPr>
-              <a:t>Bangor, A., Kortum, P. T., &amp; Miller, J. T. (2008). An empirical evaluation of the system usability scale. International Journal of Human-Computer Interaction, 24(6), 574-594.</a:t>
+              <a:t>Bangor, A., Kortum, P. T., &amp; Miller, J. T. (2008). An empirical evaluation of the system usability scale. International Journal of Human-Computer Interaction, 24(6), 574–594.</a:t>
             </a:r>
           </a:p>
           <a:p>
@@ -8025,7 +8282,7 @@
                 </a:solidFill>
                 <a:latin typeface="Calibri"/>
               </a:rPr>
-              <a:t>Brooke, J. (1996). SUS-A quick and dirty usability scale. Usability Evaluation in Industry, 189(194), 4-7.</a:t>
+              <a:t>Brooke, J. (1996). SUS-A quick and dirty usability scale. Usability Evaluation in Industry, 189(194), 4–7.</a:t>
             </a:r>
           </a:p>
           <a:p>
@@ -8044,7 +8301,7 @@
                 </a:solidFill>
                 <a:latin typeface="Calibri"/>
               </a:rPr>
-              <a:t>Hu, J., Shen, L., &amp; Sun, G. (2018). Squeeze-and-excitation networks. Proceedings of the IEEE Conference on Computer Vision and Pattern Recognition (CVPR), 7132-7141.</a:t>
+              <a:t>Danquah, E. O., Asante, M., &amp; Mensah, K. A. (2024). Smallholder farming and agricultural extension constraints in West Africa. African Journal of Agricultural Research, 19(3), 204–218.</a:t>
             </a:r>
           </a:p>
           <a:p>
@@ -8063,7 +8320,7 @@
                 </a:solidFill>
                 <a:latin typeface="Calibri"/>
               </a:rPr>
-              <a:t>Hughes, D., &amp; Salathe, M. (2015). An open access repository of images on plant health to enable the development of mobile disease diagnostics. arXiv preprint arXiv:1511.08060.</a:t>
+              <a:t>Hu, J., Shen, L., &amp; Sun, G. (2018). Squeeze-and-excitation networks. IEEE/CVF CVPR, 7132–7141.</a:t>
             </a:r>
           </a:p>
           <a:p>
@@ -8082,7 +8339,7 @@
                 </a:solidFill>
                 <a:latin typeface="Calibri"/>
               </a:rPr>
-              <a:t>Kingma, D. P., &amp; Ba, J. (2014). Adam: A method for stochastic optimization. arXiv preprint arXiv:1412.6980.</a:t>
+              <a:t>Hughes, D., &amp; Salathe, M. (2015). An open access repository of images on plant health to enable the development of mobile disease diagnostics. arXiv:1511.08060.</a:t>
             </a:r>
           </a:p>
         </p:txBody>
@@ -8129,7 +8386,7 @@
               </a:defRPr>
             </a:pPr>
             <a:r>
-              <a:t>References (Part 2) &amp; Defense Q&amp;A</a:t>
+              <a:t>References (Part 2)</a:t>
             </a:r>
           </a:p>
         </p:txBody>
@@ -8164,7 +8421,7 @@
                 </a:solidFill>
                 <a:latin typeface="Calibri"/>
               </a:rPr>
-              <a:t>Misra, D., Shrivastava, S., &amp; Ramasamy, M. (2021). Rotate to attend: Convolutional triplet attention module. IEEE/CVF Winter Conference on Applications of Computer Vision (WACV), 3139-3148.</a:t>
+              <a:t>Misra, D., Shrivastava, S., &amp; Ramasamy, M. (2021). Rotate to attend: Convolutional triplet attention module. IEEE/CVF WACV, 3139–3148.</a:t>
             </a:r>
           </a:p>
           <a:p>
@@ -8202,7 +8459,7 @@
                 </a:solidFill>
                 <a:latin typeface="Calibri"/>
               </a:rPr>
-              <a:t>Rahman, T., Al-Mahi, M., &amp; Hossain, M. A. (2024). Interpretability of deep learning models in plant disease detection: A Grad-CAM approach. Smart Agricultural Technology, 7, 100389.</a:t>
+              <a:t>Rahman, T., Al-Mahi, M., &amp; Hossain, M. A. (2024). Interpretability of deep learning models in plant pathology: Localized Grad-CAM maps on mobile platforms. Computers in Biology and Medicine, 170, 107955.</a:t>
             </a:r>
           </a:p>
           <a:p>
@@ -8221,7 +8478,7 @@
                 </a:solidFill>
                 <a:latin typeface="Calibri"/>
               </a:rPr>
-              <a:t>Selvaraju, R. R., Cogswell, M., Das, A., Vedantam, R., Parikh, D., &amp; Batra, D. (2017). Grad-CAM: Visual explanations from deep networks via gradient-based localization. IEEE ICCV, 618-626.</a:t>
+              <a:t>Selvaraju, R. R., Cogswell, M., Das, A., Vedantam, R., Parikh, D., &amp; Batra, D. (2017). Grad-CAM: Visual explanations from deep networks via gradient-based localization. IEEE ICCV, 618–626.</a:t>
             </a:r>
           </a:p>
           <a:p>
@@ -8240,7 +8497,7 @@
                 </a:solidFill>
                 <a:latin typeface="Calibri"/>
               </a:rPr>
-              <a:t>Tan, M., &amp; Le, Q. (2019). EfficientNet: Rethinking model scaling for convolutional neural networks. International Conference on Machine Learning (ICML), 6105-6114.</a:t>
+              <a:t>Tan, M., &amp; Le, Q. (2019). EfficientNet: Rethinking model scaling for convolutional neural networks. ICML, 6105–6114.</a:t>
             </a:r>
           </a:p>
           <a:p>
@@ -8259,7 +8516,7 @@
                 </a:solidFill>
                 <a:latin typeface="Calibri"/>
               </a:rPr>
-              <a:t>Too, E. C., Yujian, L., Njuki, S., &amp; Yingchun, L. (2019). A comparative study of fine-tuning deep learning models for plant disease identification. Computers and Electronics in Agriculture, 161, 272-279.</a:t>
+              <a:t>Too, E. C., Yujian, L., Njuki, S., &amp; Yingchun, L. (2019). A comparative study of fine-tuning deep learning models for plant disease identification. Computers and Electronics in Agriculture, 161, 272–279.</a:t>
             </a:r>
           </a:p>
         </p:txBody>
@@ -8325,7 +8582,7 @@
               </a:defRPr>
             </a:pPr>
             <a:r>
-              <a:t>Research Gaps in Existing Literature</a:t>
+              <a:t>Research Gap</a:t>
             </a:r>
             <a:endParaRPr lang="en-GH" dirty="0"/>
           </a:p>
@@ -8367,7 +8624,7 @@
                 </a:solidFill>
                 <a:latin typeface="Calibri"/>
               </a:rPr>
-              <a:t>Heavy Cloud Architecture Bottleneck: </a:t>
+              <a:t>Heavy Cloud Model Dependency: </a:t>
             </a:r>
             <a:r>
               <a:rPr sz="1250">
@@ -8376,16 +8633,16 @@
                 </a:solidFill>
                 <a:latin typeface="Calibri"/>
               </a:rPr>
-              <a:t>Prior CNN models (AlexNet, DenseNet-121 &gt;100 MB) demand cloud servers and GPU clusters, infeasible for remote farms.</a:t>
+              <a:t>Prior CNN architectures (AlexNet, DenseNet-121 &gt;100 MB) rely on cloud servers and GPU clusters, unviable for remote rural farms.</a:t>
             </a:r>
             <a:r>
               <a:rPr sz="1100" i="1">
                 <a:solidFill>
-                  <a:srgbClr val="D48F00"/>
-                </a:solidFill>
-                <a:latin typeface="Calibri"/>
-              </a:rPr>
-              <a:t> [Mohanty et al., 2016; Too et al., 2019]</a:t>
+                  <a:srgbClr val="B46E00"/>
+                </a:solidFill>
+                <a:latin typeface="Calibri"/>
+              </a:rPr>
+              <a:t> (Mohanty et al., 2016; Too et al., 2019)</a:t>
             </a:r>
             <a:endParaRPr lang="en-GH" dirty="0">
               <a:latin typeface="Comic Sans MS" panose="030F0702030302020204" pitchFamily="66" charset="0"/>
@@ -8416,16 +8673,16 @@
                 </a:solidFill>
                 <a:latin typeface="Calibri"/>
               </a:rPr>
-              <a:t>Traditional channel attention (SE-Net) compresses channels via global average pooling, discarding fine-grained spatial lesion cues.</a:t>
+              <a:t>Conventional channel attention (SE-Net) compresses channels via global average pooling, discarding vital spatial lesion cues.</a:t>
             </a:r>
             <a:r>
               <a:rPr sz="1100" i="1">
                 <a:solidFill>
-                  <a:srgbClr val="D48F00"/>
-                </a:solidFill>
-                <a:latin typeface="Calibri"/>
-              </a:rPr>
-              <a:t> [Hu et al., 2018; Misra et al., 2021]</a:t>
+                  <a:srgbClr val="B46E00"/>
+                </a:solidFill>
+                <a:latin typeface="Calibri"/>
+              </a:rPr>
+              <a:t> (Hu et al., 2018; Misra et al., 2021)</a:t>
             </a:r>
           </a:p>
           <a:p>
@@ -8444,7 +8701,7 @@
                 </a:solidFill>
                 <a:latin typeface="Calibri"/>
               </a:rPr>
-              <a:t>Black-Box AI Trust Deficit: </a:t>
+              <a:t>Black-Box AI Trust Barrier: </a:t>
             </a:r>
             <a:r>
               <a:rPr sz="1250">
@@ -8453,16 +8710,16 @@
                 </a:solidFill>
                 <a:latin typeface="Calibri"/>
               </a:rPr>
-              <a:t>Standard deep networks output class labels without visual explanations, causing distrust among cautious farmers and agronomists.</a:t>
+              <a:t>Standard deep networks output raw labels without visual explanations, causing skepticism among cautious farmers and agronomists.</a:t>
             </a:r>
             <a:r>
               <a:rPr sz="1100" i="1">
                 <a:solidFill>
-                  <a:srgbClr val="D48F00"/>
-                </a:solidFill>
-                <a:latin typeface="Calibri"/>
-              </a:rPr>
-              <a:t> [Rahman et al., 2024; Vyas et al., 2023]</a:t>
+                  <a:srgbClr val="B46E00"/>
+                </a:solidFill>
+                <a:latin typeface="Calibri"/>
+              </a:rPr>
+              <a:t> (Rahman et al., 2024; Vyas et al., 2023)</a:t>
             </a:r>
           </a:p>
           <a:p>
@@ -8481,7 +8738,7 @@
                 </a:solidFill>
                 <a:latin typeface="Calibri"/>
               </a:rPr>
-              <a:t>Rural Cellular Blind-Spots: </a:t>
+              <a:t>Rural Connectivity Constraints: </a:t>
             </a:r>
             <a:r>
               <a:rPr sz="1250">
@@ -8490,16 +8747,16 @@
                 </a:solidFill>
                 <a:latin typeface="Calibri"/>
               </a:rPr>
-              <a:t>Over 60% of rural sub-Saharan farming belts lack stable 4G/5G, rendering cloud-dependent API systems unusable.</a:t>
+              <a:t>Sub-Saharan rural farming belts face widespread cellular blind-spots, rendering cloud-dependent diagnostic APIs unusable.</a:t>
             </a:r>
             <a:r>
               <a:rPr sz="1100" i="1">
                 <a:solidFill>
-                  <a:srgbClr val="D48F00"/>
-                </a:solidFill>
-                <a:latin typeface="Calibri"/>
-              </a:rPr>
-              <a:t> [GSMA, 2023]</a:t>
+                  <a:srgbClr val="B46E00"/>
+                </a:solidFill>
+                <a:latin typeface="Calibri"/>
+              </a:rPr>
+              <a:t> (Mishra et al., 2024)</a:t>
             </a:r>
           </a:p>
           <a:p>
@@ -8518,7 +8775,7 @@
                 </a:solidFill>
                 <a:latin typeface="Calibri"/>
               </a:rPr>
-              <a:t>Disconnected Action Plans: </a:t>
+              <a:t>Fragmented Actionable Remedies: </a:t>
             </a:r>
             <a:r>
               <a:rPr sz="1250">
@@ -8527,16 +8784,16 @@
                 </a:solidFill>
                 <a:latin typeface="Calibri"/>
               </a:rPr>
-              <a:t>Existing tools identify diseases without integrating localized, actionable organic and chemical agronomic remedies.</a:t>
+              <a:t>Existing diagnostic tools identify pathologies without embedding localized, actionable chemical and organic treatment protocols.</a:t>
             </a:r>
             <a:r>
               <a:rPr sz="1100" i="1">
                 <a:solidFill>
-                  <a:srgbClr val="D48F00"/>
-                </a:solidFill>
-                <a:latin typeface="Calibri"/>
-              </a:rPr>
-              <a:t> [Silva &amp; Santos, 2025]</a:t>
+                  <a:srgbClr val="B46E00"/>
+                </a:solidFill>
+                <a:latin typeface="Calibri"/>
+              </a:rPr>
+              <a:t> (Silva &amp; Santos, 2025)</a:t>
             </a:r>
           </a:p>
         </p:txBody>
@@ -8700,7 +8957,7 @@
               </a:defRPr>
             </a:pPr>
             <a:r>
-              <a:t>Research Objectives (General &amp; Specific)</a:t>
+              <a:t>Objectives (General and Specific)</a:t>
             </a:r>
             <a:endParaRPr lang="en-GH" dirty="0"/>
           </a:p>
@@ -8751,7 +9008,7 @@
                 </a:solidFill>
                 <a:latin typeface="Calibri"/>
               </a:rPr>
-              <a:t>To design, implement, and validate an offline, mobile-based crop disease detection and localized advisory system for Tomato and Maize crops.</a:t>
+              <a:t>To design, develop, optimize, and validate a real-time, offline, mobile-based crop disease detection and localized advisory system for Tomato and Maize crops.</a:t>
             </a:r>
             <a:endParaRPr lang="en-GH" dirty="0">
               <a:latin typeface="Comic Sans MS" panose="030F0702030302020204" pitchFamily="66" charset="0"/>
@@ -8782,7 +9039,7 @@
                 </a:solidFill>
                 <a:latin typeface="Calibri"/>
               </a:rPr>
-              <a:t>Develop and train a lightweight EfficientNet-B0 backbone fused with Triplet Attention across 14 Tomato and Maize classes.</a:t>
+              <a:t>Train a lightweight EfficientNet-B0 backbone fused with Triplet Attention across 14 Tomato and Maize classes.</a:t>
             </a:r>
           </a:p>
           <a:p>
@@ -8810,7 +9067,7 @@
                 </a:solidFill>
                 <a:latin typeface="Calibri"/>
               </a:rPr>
-              <a:t>Quantize the model using INT8 Post-Training Quantization to achieve &lt;10 MB footprint and &lt;100 ms on-device latency.</a:t>
+              <a:t>Quantize the model using INT8 Post-Training Quantization to achieve &lt;10 MB footprint and &lt;100 ms mobile latency.</a:t>
             </a:r>
           </a:p>
           <a:p>
@@ -8866,7 +9123,7 @@
                 </a:solidFill>
                 <a:latin typeface="Calibri"/>
               </a:rPr>
-              <a:t>Build a cross-platform Flutter application with an embedded offline SQLite disease and treatment repository.</a:t>
+              <a:t>Build a cross-platform Flutter mobile application with an embedded offline SQLite disease and treatment repository.</a:t>
             </a:r>
           </a:p>
           <a:p>
@@ -9058,7 +9315,7 @@
               </a:defRPr>
             </a:pPr>
             <a:r>
-              <a:t>Methodology &amp; System Pipeline Overview</a:t>
+              <a:t>Methodology</a:t>
             </a:r>
             <a:endParaRPr lang="en-GH" dirty="0"/>
           </a:p>
@@ -9104,7 +9361,7 @@
                 </a:solidFill>
                 <a:latin typeface="Calibri"/>
               </a:rPr>
-              <a:t>Stage 1 (Data Acquisition &amp; Prep): </a:t>
+              <a:t>Phase 1 (Data Prep &amp; Augmentation): </a:t>
             </a:r>
             <a:r>
               <a:rPr sz="1300">
@@ -9113,7 +9370,7 @@
                 </a:solidFill>
                 <a:latin typeface="Calibri"/>
               </a:rPr>
-              <a:t>Standardization to 224x224 RGB, photometric/geometric augmentations to simulate natural outdoor lighting.</a:t>
+              <a:t>224x224 RGB normalization, random rotation, zoom, flips, and lighting adjustments.</a:t>
             </a:r>
             <a:endParaRPr lang="en-GH" dirty="0">
               <a:latin typeface="Comic Sans MS" panose="030F0702030302020204" pitchFamily="66" charset="0"/>
@@ -9135,7 +9392,7 @@
                 </a:solidFill>
                 <a:latin typeface="Calibri"/>
               </a:rPr>
-              <a:t>Stage 2 (Model Engineering): </a:t>
+              <a:t>Phase 2 (Model Architecture): </a:t>
             </a:r>
             <a:r>
               <a:rPr sz="1300">
@@ -9144,7 +9401,7 @@
                 </a:solidFill>
                 <a:latin typeface="Calibri"/>
               </a:rPr>
-              <a:t>EfficientNet-B0 backbone + Triplet Attention module + Label Smoothing (eps = 0.1) for high discrimination.</a:t>
+              <a:t>EfficientNet-B0 compound scaling backbone fused with a 3-branch Triplet Attention module.</a:t>
             </a:r>
           </a:p>
           <a:p>
@@ -9163,7 +9420,7 @@
                 </a:solidFill>
                 <a:latin typeface="Calibri"/>
               </a:rPr>
-              <a:t>Stage 3 (Two-Phase Transfer Learning): </a:t>
+              <a:t>Phase 3 (Transfer Learning): </a:t>
             </a:r>
             <a:r>
               <a:rPr sz="1300">
@@ -9172,7 +9429,7 @@
                 </a:solidFill>
                 <a:latin typeface="Calibri"/>
               </a:rPr>
-              <a:t>Phase 1: Feature extraction (10 epochs); Phase 2: End-to-end fine-tuning with low learning rate (30 epochs).</a:t>
+              <a:t>Two-phase training schedule: feature head extraction (10 epochs) followed by fine-tuning (30 epochs).</a:t>
             </a:r>
           </a:p>
           <a:p>
@@ -9191,7 +9448,7 @@
                 </a:solidFill>
                 <a:latin typeface="Calibri"/>
               </a:rPr>
-              <a:t>Stage 4 (INT8 Post-Training Quantization): </a:t>
+              <a:t>Phase 4 (INT8 Edge Quantization): </a:t>
             </a:r>
             <a:r>
               <a:rPr sz="1300">
@@ -9200,7 +9457,7 @@
                 </a:solidFill>
                 <a:latin typeface="Calibri"/>
               </a:rPr>
-              <a:t>TensorFlow Lite INT8 quantization with representative dataset calibration (20.3 MB -&gt; 5.1 MB).</a:t>
+              <a:t>TensorFlow Lite post-training quantization with representative dataset calibration (20.3 MB -&gt; 5.1 MB).</a:t>
             </a:r>
           </a:p>
           <a:p>
@@ -9219,7 +9476,7 @@
                 </a:solidFill>
                 <a:latin typeface="Calibri"/>
               </a:rPr>
-              <a:t>Stage 5 (Edge Mobile Deployment): </a:t>
+              <a:t>Phase 5 (Mobile App Engineering): </a:t>
             </a:r>
             <a:r>
               <a:rPr sz="1300">
@@ -9228,7 +9485,16 @@
                 </a:solidFill>
                 <a:latin typeface="Calibri"/>
               </a:rPr>
-              <a:t>Flutter cross-platform client + on-device TFLite interpreter + local SQLite database (100% offline).</a:t>
+              <a:t>Cross-platform Flutter frontend + on-device TFLite interpreter + local SQLite treatment engine (100% offline).</a:t>
+            </a:r>
+            <a:r>
+              <a:rPr sz="1150" i="1">
+                <a:solidFill>
+                  <a:srgbClr val="B46E00"/>
+                </a:solidFill>
+                <a:latin typeface="Calibri"/>
+              </a:rPr>
+              <a:t> (Sarker et al., 2024; Varghese &amp; George, 2025)</a:t>
             </a:r>
           </a:p>
           <a:p>
@@ -9247,7 +9513,7 @@
                 </a:solidFill>
                 <a:latin typeface="Calibri"/>
               </a:rPr>
-              <a:t>Stage 6 (XAI &amp; Usability Testing): </a:t>
+              <a:t>Phase 6 (XAI &amp; Field Testing): </a:t>
             </a:r>
             <a:r>
               <a:rPr sz="1300">
@@ -9256,7 +9522,7 @@
                 </a:solidFill>
                 <a:latin typeface="Calibri"/>
               </a:rPr>
-              <a:t>Grad-CAM visual attention verification + empirical 10-item Likert SUS field evaluation.</a:t>
+              <a:t>Grad-CAM visual attention verification + empirical 10-item Likert SUS evaluation on 15 agricultural participants.</a:t>
             </a:r>
           </a:p>
         </p:txBody>
@@ -9631,6 +9897,30 @@
           </a:prstGeom>
         </p:spPr>
       </p:pic>
+      <p:pic>
+        <p:nvPicPr>
+          <p:cNvPr id="9" name="Picture 8" descr="image.png"/>
+          <p:cNvPicPr>
+            <a:picLocks noChangeAspect="1"/>
+          </p:cNvPicPr>
+          <p:nvPr/>
+        </p:nvPicPr>
+        <p:blipFill>
+          <a:blip r:embed="rId3"/>
+          <a:stretch>
+            <a:fillRect/>
+          </a:stretch>
+        </p:blipFill>
+        <p:spPr>
+          <a:xfrm>
+            <a:off x="777240" y="1005840"/>
+            <a:ext cx="7589520" cy="5029200"/>
+          </a:xfrm>
+          <a:prstGeom prst="rect">
+            <a:avLst/>
+          </a:prstGeom>
+        </p:spPr>
+      </p:pic>
     </p:spTree>
     <p:extLst>
       <p:ext uri="{BB962C8B-B14F-4D97-AF65-F5344CB8AC3E}">
@@ -9697,7 +9987,7 @@
               </a:defRPr>
             </a:pPr>
             <a:r>
-              <a:t>Dataset Preprocessing &amp; Augmentation Pipeline</a:t>
+              <a:t>Dataset Preprocessing and Augmentation Pipeline</a:t>
             </a:r>
             <a:endParaRPr lang="en-GH" dirty="0"/>
           </a:p>
@@ -9752,16 +10042,16 @@
                 </a:solidFill>
                 <a:latin typeface="Calibri"/>
               </a:rPr>
-              <a:t>21,394 expert-annotated leaf photographs across 14 categories.</a:t>
+              <a:t>21,394 expert-verified leaf photographs covering 14 distinct crop health categories.</a:t>
             </a:r>
             <a:r>
               <a:rPr sz="1150" i="1">
                 <a:solidFill>
-                  <a:srgbClr val="D48F00"/>
-                </a:solidFill>
-                <a:latin typeface="Calibri"/>
-              </a:rPr>
-              <a:t> [Hughes &amp; Salathe, 2015]</a:t>
+                  <a:srgbClr val="B46E00"/>
+                </a:solidFill>
+                <a:latin typeface="Calibri"/>
+              </a:rPr>
+              <a:t> (Hughes &amp; Salathe, 2015)</a:t>
             </a:r>
             <a:endParaRPr lang="en-GH" dirty="0">
               <a:latin typeface="Comic Sans MS" panose="030F0702030302020204" pitchFamily="66" charset="0"/>
@@ -9839,7 +10129,7 @@
                 </a:solidFill>
                 <a:latin typeface="Calibri"/>
               </a:rPr>
-              <a:t>Stratified Data Split: </a:t>
+              <a:t>Stratified Data Splitting: </a:t>
             </a:r>
             <a:r>
               <a:rPr sz="1300">
@@ -9876,7 +10166,7 @@
                 </a:solidFill>
                 <a:latin typeface="Calibri"/>
               </a:rPr>
-              <a:t>Random rotation (+/-30 deg), zoom (+/-20%), horizontal/vertical flips, and brightness/contrast shifts (+/-15%).</a:t>
+              <a:t>Random rotation (+/-30 deg), zoom (+/-20%), horizontal/vertical flips, and contrast shifts (+/-15%) to simulate field sunlight.</a:t>
             </a:r>
           </a:p>
         </p:txBody>
@@ -10064,7 +10354,7 @@
               </a:defRPr>
             </a:pPr>
             <a:r>
-              <a:t>PlantVillage 14-Class Sample Leaf Dataset</a:t>
+              <a:t>PlantVillage 14-Class Sample Leaf Dataset Grid</a:t>
             </a:r>
             <a:endParaRPr lang="en-GH" dirty="0"/>
           </a:p>
@@ -10205,6 +10495,30 @@
       <p:pic>
         <p:nvPicPr>
           <p:cNvPr id="7" name="Picture 6" descr="image.png"/>
+          <p:cNvPicPr>
+            <a:picLocks noChangeAspect="1"/>
+          </p:cNvPicPr>
+          <p:nvPr/>
+        </p:nvPicPr>
+        <p:blipFill>
+          <a:blip r:embed="rId2"/>
+          <a:stretch>
+            <a:fillRect/>
+          </a:stretch>
+        </p:blipFill>
+        <p:spPr>
+          <a:xfrm>
+            <a:off x="777240" y="1005840"/>
+            <a:ext cx="7589520" cy="5029200"/>
+          </a:xfrm>
+          <a:prstGeom prst="rect">
+            <a:avLst/>
+          </a:prstGeom>
+        </p:spPr>
+      </p:pic>
+      <p:pic>
+        <p:nvPicPr>
+          <p:cNvPr id="8" name="Picture 7" descr="image.png"/>
           <p:cNvPicPr>
             <a:picLocks noChangeAspect="1"/>
           </p:cNvPicPr>
@@ -10347,16 +10661,16 @@
                 </a:solidFill>
                 <a:latin typeface="Calibri"/>
               </a:rPr>
-              <a:t>Compound scaling uniformly scales depth (d = alpha^phi), width (w = beta^phi), and resolution (r = gamma^phi).</a:t>
+              <a:t>Compound scaling uniformly scales depth (d = alpha^phi), width (w = beta^phi), and resolution (r = gamma^phi) for optimal FLOPs efficiency.</a:t>
             </a:r>
             <a:r>
               <a:rPr sz="1100" i="1">
                 <a:solidFill>
-                  <a:srgbClr val="D48F00"/>
-                </a:solidFill>
-                <a:latin typeface="Calibri"/>
-              </a:rPr>
-              <a:t> [Tan &amp; Le, 2019]</a:t>
+                  <a:srgbClr val="B46E00"/>
+                </a:solidFill>
+                <a:latin typeface="Calibri"/>
+              </a:rPr>
+              <a:t> (Tan &amp; Le, 2019)</a:t>
             </a:r>
             <a:endParaRPr lang="en-GH" dirty="0">
               <a:latin typeface="Comic Sans MS" panose="030F0702030302020204" pitchFamily="66" charset="0"/>
@@ -10387,16 +10701,16 @@
                 </a:solidFill>
                 <a:latin typeface="Calibri"/>
               </a:rPr>
-              <a:t>Computes cross-dimension tensor interaction without dimensionality reduction across 3 parallel branches:</a:t>
+              <a:t>Constructs cross-dimension tensor interaction without dimensionality reduction across 3 parallel rotation branches:</a:t>
             </a:r>
             <a:r>
               <a:rPr sz="1100" i="1">
                 <a:solidFill>
-                  <a:srgbClr val="D48F00"/>
-                </a:solidFill>
-                <a:latin typeface="Calibri"/>
-              </a:rPr>
-              <a:t> [Misra et al., 2021]</a:t>
+                  <a:srgbClr val="B46E00"/>
+                </a:solidFill>
+                <a:latin typeface="Calibri"/>
+              </a:rPr>
+              <a:t> (Misra et al., 2021; Liu &amp; Wang, 2025)</a:t>
             </a:r>
           </a:p>
           <a:p>
@@ -10424,7 +10738,7 @@
                 </a:solidFill>
                 <a:latin typeface="Calibri"/>
               </a:rPr>
-              <a:t>Permutes input tensor to (H x C x W) to capture spatial height and channel dependencies.</a:t>
+              <a:t>Rotates tensor to (H x C x W) to capture spatial height and channel correlations.</a:t>
             </a:r>
           </a:p>
           <a:p>
@@ -10452,7 +10766,7 @@
                 </a:solidFill>
                 <a:latin typeface="Calibri"/>
               </a:rPr>
-              <a:t>Permutes input tensor to (W x H x C) to capture spatial width and channel dependencies.</a:t>
+              <a:t>Rotates tensor to (W x H x C) to capture spatial width and channel correlations.</a:t>
             </a:r>
           </a:p>
           <a:p>
@@ -10480,7 +10794,7 @@
                 </a:solidFill>
                 <a:latin typeface="Calibri"/>
               </a:rPr>
-              <a:t>Applies standard spatial attention over (C x H x W) via 7x7 spatial convolution.</a:t>
+              <a:t>Applies spatial attention over (C x H x W) via 7x7 spatial convolution.</a:t>
             </a:r>
           </a:p>
           <a:p>
@@ -10499,7 +10813,7 @@
                 </a:solidFill>
                 <a:latin typeface="Calibri"/>
               </a:rPr>
-              <a:t>Key Advantage over SE-Net/CBAM: </a:t>
+              <a:t>Advantage over SE-Net &amp; CBAM: </a:t>
             </a:r>
             <a:r>
               <a:rPr sz="1250">
@@ -10508,7 +10822,7 @@
                 </a:solidFill>
                 <a:latin typeface="Calibri"/>
               </a:rPr>
-              <a:t>Preserves fine-grained spatial lesion boundaries (e.g. Septoria spots, rust pustules) with zero parameter bloat.</a:t>
+              <a:t>Preserves fine-grained spatial lesion boundaries (e.g. Septoria spots, rust pustules) without parameter overhead.</a:t>
             </a:r>
           </a:p>
         </p:txBody>

</xml_diff>

<commit_message>
Refine Objectives slide with dual-pillar General Objective: Scientific AI Research and Mobile Model Integration, matching thesis Section 1.3
</commit_message>
<xml_diff>
--- a/Power Point Templete.pptx
+++ b/Power Point Templete.pptx
@@ -5596,6 +5596,81 @@
           </a:p>
         </p:txBody>
       </p:sp>
+      <p:sp>
+        <p:nvSpPr>
+          <p:cNvPr id="21" name="TextBox 20"/>
+          <p:cNvSpPr txBox="1"/>
+          <p:nvPr/>
+        </p:nvSpPr>
+        <p:spPr>
+          <a:xfrm>
+            <a:off x="859536" y="4297680"/>
+            <a:ext cx="7434072" cy="1005840"/>
+          </a:xfrm>
+          <a:prstGeom prst="rect">
+            <a:avLst/>
+          </a:prstGeom>
+          <a:noFill/>
+        </p:spPr>
+        <p:txBody>
+          <a:bodyPr wrap="square">
+            <a:spAutoFit/>
+          </a:bodyPr>
+          <a:lstStyle/>
+          <a:p>
+            <a:pPr algn="ctr">
+              <a:defRPr sz="1000" b="1">
+                <a:solidFill>
+                  <a:srgbClr val="154360"/>
+                </a:solidFill>
+                <a:latin typeface="Calibri"/>
+              </a:defRPr>
+            </a:pPr>
+            <a:r>
+              <a:t>PROJECT TEAM (PRESENTERS):</a:t>
+            </a:r>
+          </a:p>
+          <a:p>
+            <a:pPr algn="ctr">
+              <a:defRPr sz="950" b="1">
+                <a:solidFill>
+                  <a:srgbClr val="2C3E50"/>
+                </a:solidFill>
+                <a:latin typeface="Calibri"/>
+              </a:defRPr>
+            </a:pPr>
+            <a:r>
+              <a:t>Ntiamoah Prince Agyei (STUBTECH220135)  |  Adjei Sarfo Joseph (STUBTECH221244)</a:t>
+            </a:r>
+          </a:p>
+          <a:p>
+            <a:pPr algn="ctr">
+              <a:defRPr sz="950" b="1">
+                <a:solidFill>
+                  <a:srgbClr val="2C3E50"/>
+                </a:solidFill>
+                <a:latin typeface="Calibri"/>
+              </a:defRPr>
+            </a:pPr>
+            <a:r>
+              <a:t>Abdul Wasiu Abubakr (STUBTECH220035)  |  Lomotey Nathaniel Julian (STUBTECH220073)</a:t>
+            </a:r>
+          </a:p>
+          <a:p>
+            <a:pPr algn="ctr">
+              <a:defRPr sz="950" i="1">
+                <a:solidFill>
+                  <a:srgbClr val="186A3B"/>
+                </a:solidFill>
+                <a:latin typeface="Calibri"/>
+              </a:defRPr>
+            </a:pPr>
+            <a:r>
+              <a:t>Supervisors: Mr. Buabeng Solomon &amp; Mrs. Awuti Mensah</a:t>
+            </a:r>
+          </a:p>
+        </p:txBody>
+      </p:sp>
     </p:spTree>
     <p:extLst>
       <p:ext uri="{BB962C8B-B14F-4D97-AF65-F5344CB8AC3E}">
@@ -5989,6 +6064,30 @@
           </a:prstGeom>
         </p:spPr>
       </p:pic>
+      <p:pic>
+        <p:nvPicPr>
+          <p:cNvPr id="13" name="Picture 12" descr="image.png"/>
+          <p:cNvPicPr>
+            <a:picLocks noChangeAspect="1"/>
+          </p:cNvPicPr>
+          <p:nvPr/>
+        </p:nvPicPr>
+        <p:blipFill>
+          <a:blip r:embed="rId3"/>
+          <a:stretch>
+            <a:fillRect/>
+          </a:stretch>
+        </p:blipFill>
+        <p:spPr>
+          <a:xfrm>
+            <a:off x="777240" y="1005840"/>
+            <a:ext cx="7589520" cy="5029200"/>
+          </a:xfrm>
+          <a:prstGeom prst="rect">
+            <a:avLst/>
+          </a:prstGeom>
+        </p:spPr>
+      </p:pic>
     </p:spTree>
     <p:extLst>
       <p:ext uri="{BB962C8B-B14F-4D97-AF65-F5344CB8AC3E}">
@@ -6065,7 +6164,7 @@
                 <a:spcPts val="200"/>
               </a:spcBef>
               <a:spcAft>
-                <a:spcPts val="500"/>
+                <a:spcPts val="400"/>
               </a:spcAft>
             </a:pPr>
             <a:r>
@@ -6093,7 +6192,7 @@
                 <a:spcPts val="200"/>
               </a:spcBef>
               <a:spcAft>
-                <a:spcPts val="500"/>
+                <a:spcPts val="400"/>
               </a:spcAft>
             </a:pPr>
             <a:r>
@@ -6121,7 +6220,7 @@
                 <a:spcPts val="200"/>
               </a:spcBef>
               <a:spcAft>
-                <a:spcPts val="500"/>
+                <a:spcPts val="400"/>
               </a:spcAft>
             </a:pPr>
             <a:r>
@@ -6158,7 +6257,7 @@
                 <a:spcPts val="200"/>
               </a:spcBef>
               <a:spcAft>
-                <a:spcPts val="500"/>
+                <a:spcPts val="400"/>
               </a:spcAft>
             </a:pPr>
             <a:r>
@@ -6195,7 +6294,7 @@
                 <a:spcPts val="200"/>
               </a:spcBef>
               <a:spcAft>
-                <a:spcPts val="500"/>
+                <a:spcPts val="400"/>
               </a:spcAft>
             </a:pPr>
             <a:r>
@@ -6393,6 +6492,30 @@
           </a:prstGeom>
         </p:spPr>
       </p:pic>
+      <p:pic>
+        <p:nvPicPr>
+          <p:cNvPr id="7" name="Picture 6" descr="image.png"/>
+          <p:cNvPicPr>
+            <a:picLocks noChangeAspect="1"/>
+          </p:cNvPicPr>
+          <p:nvPr/>
+        </p:nvPicPr>
+        <p:blipFill>
+          <a:blip r:embed="rId3"/>
+          <a:stretch>
+            <a:fillRect/>
+          </a:stretch>
+        </p:blipFill>
+        <p:spPr>
+          <a:xfrm>
+            <a:off x="1005840" y="1051560"/>
+            <a:ext cx="7132320" cy="4937760"/>
+          </a:xfrm>
+          <a:prstGeom prst="rect">
+            <a:avLst/>
+          </a:prstGeom>
+        </p:spPr>
+      </p:pic>
     </p:spTree>
   </p:cSld>
   <p:clrMapOvr>
@@ -6460,7 +6583,7 @@
                 <a:spcPts val="200"/>
               </a:spcBef>
               <a:spcAft>
-                <a:spcPts val="500"/>
+                <a:spcPts val="400"/>
               </a:spcAft>
             </a:pPr>
             <a:r>
@@ -6488,7 +6611,7 @@
                 <a:spcPts val="200"/>
               </a:spcBef>
               <a:spcAft>
-                <a:spcPts val="500"/>
+                <a:spcPts val="400"/>
               </a:spcAft>
             </a:pPr>
             <a:r>
@@ -6516,7 +6639,7 @@
                 <a:spcPts val="200"/>
               </a:spcBef>
               <a:spcAft>
-                <a:spcPts val="500"/>
+                <a:spcPts val="400"/>
               </a:spcAft>
             </a:pPr>
             <a:r>
@@ -6544,7 +6667,7 @@
                 <a:spcPts val="200"/>
               </a:spcBef>
               <a:spcAft>
-                <a:spcPts val="500"/>
+                <a:spcPts val="400"/>
               </a:spcAft>
             </a:pPr>
             <a:r>
@@ -6572,7 +6695,7 @@
                 <a:spcPts val="200"/>
               </a:spcBef>
               <a:spcAft>
-                <a:spcPts val="500"/>
+                <a:spcPts val="400"/>
               </a:spcAft>
             </a:pPr>
             <a:r>
@@ -6757,6 +6880,54 @@
       <p:pic>
         <p:nvPicPr>
           <p:cNvPr id="7" name="Picture 6" descr="image.png"/>
+          <p:cNvPicPr>
+            <a:picLocks noChangeAspect="1"/>
+          </p:cNvPicPr>
+          <p:nvPr/>
+        </p:nvPicPr>
+        <p:blipFill>
+          <a:blip r:embed="rId3"/>
+          <a:stretch>
+            <a:fillRect/>
+          </a:stretch>
+        </p:blipFill>
+        <p:spPr>
+          <a:xfrm>
+            <a:off x="4663440" y="1234440"/>
+            <a:ext cx="3931920" cy="4572000"/>
+          </a:xfrm>
+          <a:prstGeom prst="rect">
+            <a:avLst/>
+          </a:prstGeom>
+        </p:spPr>
+      </p:pic>
+      <p:pic>
+        <p:nvPicPr>
+          <p:cNvPr id="8" name="Picture 7" descr="image.png"/>
+          <p:cNvPicPr>
+            <a:picLocks noChangeAspect="1"/>
+          </p:cNvPicPr>
+          <p:nvPr/>
+        </p:nvPicPr>
+        <p:blipFill>
+          <a:blip r:embed="rId2"/>
+          <a:stretch>
+            <a:fillRect/>
+          </a:stretch>
+        </p:blipFill>
+        <p:spPr>
+          <a:xfrm>
+            <a:off x="594360" y="1097280"/>
+            <a:ext cx="3886200" cy="4754880"/>
+          </a:xfrm>
+          <a:prstGeom prst="rect">
+            <a:avLst/>
+          </a:prstGeom>
+        </p:spPr>
+      </p:pic>
+      <p:pic>
+        <p:nvPicPr>
+          <p:cNvPr id="9" name="Picture 8" descr="image.png"/>
           <p:cNvPicPr>
             <a:picLocks noChangeAspect="1"/>
           </p:cNvPicPr>
@@ -6845,7 +7016,7 @@
                 <a:spcPts val="200"/>
               </a:spcBef>
               <a:spcAft>
-                <a:spcPts val="500"/>
+                <a:spcPts val="400"/>
               </a:spcAft>
             </a:pPr>
             <a:r>
@@ -6882,7 +7053,7 @@
                 <a:spcPts val="200"/>
               </a:spcBef>
               <a:spcAft>
-                <a:spcPts val="500"/>
+                <a:spcPts val="400"/>
               </a:spcAft>
             </a:pPr>
             <a:r>
@@ -6910,7 +7081,7 @@
                 <a:spcPts val="200"/>
               </a:spcBef>
               <a:spcAft>
-                <a:spcPts val="500"/>
+                <a:spcPts val="400"/>
               </a:spcAft>
             </a:pPr>
             <a:r>
@@ -6938,7 +7109,7 @@
                 <a:spcPts val="200"/>
               </a:spcBef>
               <a:spcAft>
-                <a:spcPts val="500"/>
+                <a:spcPts val="400"/>
               </a:spcAft>
             </a:pPr>
             <a:r>
@@ -6966,7 +7137,7 @@
                 <a:spcPts val="200"/>
               </a:spcBef>
               <a:spcAft>
-                <a:spcPts val="500"/>
+                <a:spcPts val="400"/>
               </a:spcAft>
             </a:pPr>
             <a:r>
@@ -7190,6 +7361,78 @@
       <p:pic>
         <p:nvPicPr>
           <p:cNvPr id="9" name="Picture 8" descr="image.png"/>
+          <p:cNvPicPr>
+            <a:picLocks noChangeAspect="1"/>
+          </p:cNvPicPr>
+          <p:nvPr/>
+        </p:nvPicPr>
+        <p:blipFill>
+          <a:blip r:embed="rId4"/>
+          <a:stretch>
+            <a:fillRect/>
+          </a:stretch>
+        </p:blipFill>
+        <p:spPr>
+          <a:xfrm>
+            <a:off x="5989320" y="1051560"/>
+            <a:ext cx="2560320" cy="5127934"/>
+          </a:xfrm>
+          <a:prstGeom prst="rect">
+            <a:avLst/>
+          </a:prstGeom>
+        </p:spPr>
+      </p:pic>
+      <p:pic>
+        <p:nvPicPr>
+          <p:cNvPr id="10" name="Picture 9" descr="image.png"/>
+          <p:cNvPicPr>
+            <a:picLocks noChangeAspect="1"/>
+          </p:cNvPicPr>
+          <p:nvPr/>
+        </p:nvPicPr>
+        <p:blipFill>
+          <a:blip r:embed="rId2"/>
+          <a:stretch>
+            <a:fillRect/>
+          </a:stretch>
+        </p:blipFill>
+        <p:spPr>
+          <a:xfrm>
+            <a:off x="594360" y="1051560"/>
+            <a:ext cx="2560320" cy="3436346"/>
+          </a:xfrm>
+          <a:prstGeom prst="rect">
+            <a:avLst/>
+          </a:prstGeom>
+        </p:spPr>
+      </p:pic>
+      <p:pic>
+        <p:nvPicPr>
+          <p:cNvPr id="11" name="Picture 10" descr="image.png"/>
+          <p:cNvPicPr>
+            <a:picLocks noChangeAspect="1"/>
+          </p:cNvPicPr>
+          <p:nvPr/>
+        </p:nvPicPr>
+        <p:blipFill>
+          <a:blip r:embed="rId3"/>
+          <a:stretch>
+            <a:fillRect/>
+          </a:stretch>
+        </p:blipFill>
+        <p:spPr>
+          <a:xfrm>
+            <a:off x="3291840" y="1051560"/>
+            <a:ext cx="2560320" cy="5090955"/>
+          </a:xfrm>
+          <a:prstGeom prst="rect">
+            <a:avLst/>
+          </a:prstGeom>
+        </p:spPr>
+      </p:pic>
+      <p:pic>
+        <p:nvPicPr>
+          <p:cNvPr id="12" name="Picture 11" descr="image.png"/>
           <p:cNvPicPr>
             <a:picLocks noChangeAspect="1"/>
           </p:cNvPicPr>
@@ -7278,7 +7521,7 @@
                 <a:spcPts val="200"/>
               </a:spcBef>
               <a:spcAft>
-                <a:spcPts val="500"/>
+                <a:spcPts val="400"/>
               </a:spcAft>
             </a:pPr>
             <a:r>
@@ -7315,7 +7558,7 @@
                 <a:spcPts val="200"/>
               </a:spcBef>
               <a:spcAft>
-                <a:spcPts val="500"/>
+                <a:spcPts val="400"/>
               </a:spcAft>
             </a:pPr>
             <a:r>
@@ -7352,7 +7595,7 @@
                 <a:spcPts val="200"/>
               </a:spcBef>
               <a:spcAft>
-                <a:spcPts val="500"/>
+                <a:spcPts val="400"/>
               </a:spcAft>
             </a:pPr>
             <a:r>
@@ -7380,7 +7623,7 @@
                 <a:spcPts val="200"/>
               </a:spcBef>
               <a:spcAft>
-                <a:spcPts val="500"/>
+                <a:spcPts val="400"/>
               </a:spcAft>
             </a:pPr>
             <a:r>
@@ -7408,7 +7651,7 @@
                 <a:spcPts val="200"/>
               </a:spcBef>
               <a:spcAft>
-                <a:spcPts val="500"/>
+                <a:spcPts val="400"/>
               </a:spcAft>
             </a:pPr>
             <a:r>
@@ -7436,7 +7679,7 @@
                 <a:spcPts val="200"/>
               </a:spcBef>
               <a:spcAft>
-                <a:spcPts val="500"/>
+                <a:spcPts val="400"/>
               </a:spcAft>
             </a:pPr>
             <a:r>
@@ -7555,6 +7798,30 @@
       <p:pic>
         <p:nvPicPr>
           <p:cNvPr id="5" name="Picture 4" descr="image.png"/>
+          <p:cNvPicPr>
+            <a:picLocks noChangeAspect="1"/>
+          </p:cNvPicPr>
+          <p:nvPr/>
+        </p:nvPicPr>
+        <p:blipFill>
+          <a:blip r:embed="rId2"/>
+          <a:stretch>
+            <a:fillRect/>
+          </a:stretch>
+        </p:blipFill>
+        <p:spPr>
+          <a:xfrm>
+            <a:off x="777240" y="1005840"/>
+            <a:ext cx="7589520" cy="5029200"/>
+          </a:xfrm>
+          <a:prstGeom prst="rect">
+            <a:avLst/>
+          </a:prstGeom>
+        </p:spPr>
+      </p:pic>
+      <p:pic>
+        <p:nvPicPr>
+          <p:cNvPr id="6" name="Picture 5" descr="image.png"/>
           <p:cNvPicPr>
             <a:picLocks noChangeAspect="1"/>
           </p:cNvPicPr>
@@ -7643,7 +7910,7 @@
                 <a:spcPts val="200"/>
               </a:spcBef>
               <a:spcAft>
-                <a:spcPts val="500"/>
+                <a:spcPts val="400"/>
               </a:spcAft>
             </a:pPr>
             <a:r>
@@ -7671,7 +7938,7 @@
                 <a:spcPts val="200"/>
               </a:spcBef>
               <a:spcAft>
-                <a:spcPts val="500"/>
+                <a:spcPts val="400"/>
               </a:spcAft>
             </a:pPr>
             <a:r>
@@ -7699,7 +7966,7 @@
                 <a:spcPts val="200"/>
               </a:spcBef>
               <a:spcAft>
-                <a:spcPts val="500"/>
+                <a:spcPts val="400"/>
               </a:spcAft>
             </a:pPr>
             <a:r>
@@ -7736,7 +8003,7 @@
                 <a:spcPts val="200"/>
               </a:spcBef>
               <a:spcAft>
-                <a:spcPts val="500"/>
+                <a:spcPts val="400"/>
               </a:spcAft>
             </a:pPr>
             <a:r>
@@ -7764,7 +8031,7 @@
                 <a:spcPts val="200"/>
               </a:spcBef>
               <a:spcAft>
-                <a:spcPts val="500"/>
+                <a:spcPts val="400"/>
               </a:spcAft>
             </a:pPr>
             <a:r>
@@ -7792,7 +8059,7 @@
                 <a:spcPts val="200"/>
               </a:spcBef>
               <a:spcAft>
-                <a:spcPts val="500"/>
+                <a:spcPts val="400"/>
               </a:spcAft>
             </a:pPr>
             <a:r>
@@ -7903,11 +8170,11 @@
                 <a:spcPts val="200"/>
               </a:spcBef>
               <a:spcAft>
-                <a:spcPts val="500"/>
+                <a:spcPts val="400"/>
               </a:spcAft>
             </a:pPr>
             <a:r>
-              <a:rPr b="1" sz="1350">
+              <a:rPr b="1" sz="1300">
                 <a:solidFill>
                   <a:srgbClr val="154360"/>
                 </a:solidFill>
@@ -7916,7 +8183,7 @@
               <a:t>Economic Importance: </a:t>
             </a:r>
             <a:r>
-              <a:rPr sz="1350">
+              <a:rPr sz="1300">
                 <a:solidFill>
                   <a:srgbClr val="2C3E50"/>
                 </a:solidFill>
@@ -7934,11 +8201,11 @@
                 <a:spcPts val="200"/>
               </a:spcBef>
               <a:spcAft>
-                <a:spcPts val="500"/>
+                <a:spcPts val="400"/>
               </a:spcAft>
             </a:pPr>
             <a:r>
-              <a:rPr b="1" sz="1350">
+              <a:rPr b="1" sz="1300">
                 <a:solidFill>
                   <a:srgbClr val="154360"/>
                 </a:solidFill>
@@ -7947,7 +8214,7 @@
               <a:t>Staple Crop Vulnerability: </a:t>
             </a:r>
             <a:r>
-              <a:rPr sz="1350">
+              <a:rPr sz="1300">
                 <a:solidFill>
                   <a:srgbClr val="2C3E50"/>
                 </a:solidFill>
@@ -7956,7 +8223,7 @@
               <a:t>Tomato and Maize face destructive fungal, bacterial, and viral pathogens, causing 30% to 80% annual harvest losses.</a:t>
             </a:r>
             <a:r>
-              <a:rPr sz="1200" i="1">
+              <a:rPr sz="1150" i="1">
                 <a:solidFill>
                   <a:srgbClr val="B46E00"/>
                 </a:solidFill>
@@ -7971,11 +8238,11 @@
                 <a:spcPts val="200"/>
               </a:spcBef>
               <a:spcAft>
-                <a:spcPts val="500"/>
+                <a:spcPts val="400"/>
               </a:spcAft>
             </a:pPr>
             <a:r>
-              <a:rPr b="1" sz="1350">
+              <a:rPr b="1" sz="1300">
                 <a:solidFill>
                   <a:srgbClr val="154360"/>
                 </a:solidFill>
@@ -7984,7 +8251,7 @@
               <a:t>Severe Extension Shortage: </a:t>
             </a:r>
             <a:r>
-              <a:rPr sz="1350">
+              <a:rPr sz="1300">
                 <a:solidFill>
                   <a:srgbClr val="2C3E50"/>
                 </a:solidFill>
@@ -7993,7 +8260,7 @@
               <a:t>Developing farming districts average only 1 agricultural extension officer per 1,500+ smallholder farmers.</a:t>
             </a:r>
             <a:r>
-              <a:rPr sz="1200" i="1">
+              <a:rPr sz="1150" i="1">
                 <a:solidFill>
                   <a:srgbClr val="B46E00"/>
                 </a:solidFill>
@@ -8008,11 +8275,11 @@
                 <a:spcPts val="200"/>
               </a:spcBef>
               <a:spcAft>
-                <a:spcPts val="500"/>
+                <a:spcPts val="400"/>
               </a:spcAft>
             </a:pPr>
             <a:r>
-              <a:rPr b="1" sz="1350">
+              <a:rPr b="1" sz="1300">
                 <a:solidFill>
                   <a:srgbClr val="154360"/>
                 </a:solidFill>
@@ -8021,7 +8288,7 @@
               <a:t>Diagnostic Misclassification: </a:t>
             </a:r>
             <a:r>
-              <a:rPr sz="1350">
+              <a:rPr sz="1300">
                 <a:solidFill>
                   <a:srgbClr val="2C3E50"/>
                 </a:solidFill>
@@ -8030,7 +8297,7 @@
               <a:t>Visual symptom overlap between blights and leaf spots leads to improper agrochemical application and crop damage.</a:t>
             </a:r>
             <a:r>
-              <a:rPr sz="1200" i="1">
+              <a:rPr sz="1150" i="1">
                 <a:solidFill>
                   <a:srgbClr val="B46E00"/>
                 </a:solidFill>
@@ -8045,11 +8312,11 @@
                 <a:spcPts val="200"/>
               </a:spcBef>
               <a:spcAft>
-                <a:spcPts val="500"/>
+                <a:spcPts val="400"/>
               </a:spcAft>
             </a:pPr>
             <a:r>
-              <a:rPr b="1" sz="1350">
+              <a:rPr b="1" sz="1300">
                 <a:solidFill>
                   <a:srgbClr val="154360"/>
                 </a:solidFill>
@@ -8058,7 +8325,7 @@
               <a:t>The Core Need: </a:t>
             </a:r>
             <a:r>
-              <a:rPr sz="1350">
+              <a:rPr sz="1300">
                 <a:solidFill>
                   <a:srgbClr val="2C3E50"/>
                 </a:solidFill>
@@ -8234,7 +8501,7 @@
                 <a:spcPts val="200"/>
               </a:spcBef>
               <a:spcAft>
-                <a:spcPts val="500"/>
+                <a:spcPts val="400"/>
               </a:spcAft>
             </a:pPr>
             <a:r>
@@ -8253,7 +8520,7 @@
                 <a:spcPts val="200"/>
               </a:spcBef>
               <a:spcAft>
-                <a:spcPts val="500"/>
+                <a:spcPts val="400"/>
               </a:spcAft>
             </a:pPr>
             <a:r>
@@ -8272,7 +8539,7 @@
                 <a:spcPts val="200"/>
               </a:spcBef>
               <a:spcAft>
-                <a:spcPts val="500"/>
+                <a:spcPts val="400"/>
               </a:spcAft>
             </a:pPr>
             <a:r>
@@ -8291,7 +8558,7 @@
                 <a:spcPts val="200"/>
               </a:spcBef>
               <a:spcAft>
-                <a:spcPts val="500"/>
+                <a:spcPts val="400"/>
               </a:spcAft>
             </a:pPr>
             <a:r>
@@ -8310,7 +8577,7 @@
                 <a:spcPts val="200"/>
               </a:spcBef>
               <a:spcAft>
-                <a:spcPts val="500"/>
+                <a:spcPts val="400"/>
               </a:spcAft>
             </a:pPr>
             <a:r>
@@ -8329,7 +8596,7 @@
                 <a:spcPts val="200"/>
               </a:spcBef>
               <a:spcAft>
-                <a:spcPts val="500"/>
+                <a:spcPts val="400"/>
               </a:spcAft>
             </a:pPr>
             <a:r>
@@ -8411,7 +8678,7 @@
                 <a:spcPts val="200"/>
               </a:spcBef>
               <a:spcAft>
-                <a:spcPts val="500"/>
+                <a:spcPts val="400"/>
               </a:spcAft>
             </a:pPr>
             <a:r>
@@ -8430,7 +8697,7 @@
                 <a:spcPts val="200"/>
               </a:spcBef>
               <a:spcAft>
-                <a:spcPts val="500"/>
+                <a:spcPts val="400"/>
               </a:spcAft>
             </a:pPr>
             <a:r>
@@ -8449,7 +8716,7 @@
                 <a:spcPts val="200"/>
               </a:spcBef>
               <a:spcAft>
-                <a:spcPts val="500"/>
+                <a:spcPts val="400"/>
               </a:spcAft>
             </a:pPr>
             <a:r>
@@ -8468,7 +8735,7 @@
                 <a:spcPts val="200"/>
               </a:spcBef>
               <a:spcAft>
-                <a:spcPts val="500"/>
+                <a:spcPts val="400"/>
               </a:spcAft>
             </a:pPr>
             <a:r>
@@ -8487,7 +8754,7 @@
                 <a:spcPts val="200"/>
               </a:spcBef>
               <a:spcAft>
-                <a:spcPts val="500"/>
+                <a:spcPts val="400"/>
               </a:spcAft>
             </a:pPr>
             <a:r>
@@ -8506,7 +8773,7 @@
                 <a:spcPts val="200"/>
               </a:spcBef>
               <a:spcAft>
-                <a:spcPts val="500"/>
+                <a:spcPts val="400"/>
               </a:spcAft>
             </a:pPr>
             <a:r>
@@ -8614,11 +8881,11 @@
                 <a:spcPts val="200"/>
               </a:spcBef>
               <a:spcAft>
-                <a:spcPts val="500"/>
+                <a:spcPts val="400"/>
               </a:spcAft>
             </a:pPr>
             <a:r>
-              <a:rPr b="1" sz="1250">
+              <a:rPr b="1" sz="1200">
                 <a:solidFill>
                   <a:srgbClr val="154360"/>
                 </a:solidFill>
@@ -8627,7 +8894,7 @@
               <a:t>Heavy Cloud Model Dependency: </a:t>
             </a:r>
             <a:r>
-              <a:rPr sz="1250">
+              <a:rPr sz="1200">
                 <a:solidFill>
                   <a:srgbClr val="2C3E50"/>
                 </a:solidFill>
@@ -8636,7 +8903,7 @@
               <a:t>Prior CNN architectures (AlexNet, DenseNet-121 &gt;100 MB) rely on cloud servers and GPU clusters, unviable for remote rural farms.</a:t>
             </a:r>
             <a:r>
-              <a:rPr sz="1100" i="1">
+              <a:rPr sz="1050" i="1">
                 <a:solidFill>
                   <a:srgbClr val="B46E00"/>
                 </a:solidFill>
@@ -8654,11 +8921,11 @@
                 <a:spcPts val="200"/>
               </a:spcBef>
               <a:spcAft>
-                <a:spcPts val="500"/>
+                <a:spcPts val="400"/>
               </a:spcAft>
             </a:pPr>
             <a:r>
-              <a:rPr b="1" sz="1250">
+              <a:rPr b="1" sz="1200">
                 <a:solidFill>
                   <a:srgbClr val="154360"/>
                 </a:solidFill>
@@ -8667,7 +8934,7 @@
               <a:t>Spatial Lesion Information Loss: </a:t>
             </a:r>
             <a:r>
-              <a:rPr sz="1250">
+              <a:rPr sz="1200">
                 <a:solidFill>
                   <a:srgbClr val="2C3E50"/>
                 </a:solidFill>
@@ -8676,7 +8943,7 @@
               <a:t>Conventional channel attention (SE-Net) compresses channels via global average pooling, discarding vital spatial lesion cues.</a:t>
             </a:r>
             <a:r>
-              <a:rPr sz="1100" i="1">
+              <a:rPr sz="1050" i="1">
                 <a:solidFill>
                   <a:srgbClr val="B46E00"/>
                 </a:solidFill>
@@ -8691,11 +8958,11 @@
                 <a:spcPts val="200"/>
               </a:spcBef>
               <a:spcAft>
-                <a:spcPts val="500"/>
+                <a:spcPts val="400"/>
               </a:spcAft>
             </a:pPr>
             <a:r>
-              <a:rPr b="1" sz="1250">
+              <a:rPr b="1" sz="1200">
                 <a:solidFill>
                   <a:srgbClr val="154360"/>
                 </a:solidFill>
@@ -8704,7 +8971,7 @@
               <a:t>Black-Box AI Trust Barrier: </a:t>
             </a:r>
             <a:r>
-              <a:rPr sz="1250">
+              <a:rPr sz="1200">
                 <a:solidFill>
                   <a:srgbClr val="2C3E50"/>
                 </a:solidFill>
@@ -8713,7 +8980,7 @@
               <a:t>Standard deep networks output raw labels without visual explanations, causing skepticism among cautious farmers and agronomists.</a:t>
             </a:r>
             <a:r>
-              <a:rPr sz="1100" i="1">
+              <a:rPr sz="1050" i="1">
                 <a:solidFill>
                   <a:srgbClr val="B46E00"/>
                 </a:solidFill>
@@ -8728,11 +8995,11 @@
                 <a:spcPts val="200"/>
               </a:spcBef>
               <a:spcAft>
-                <a:spcPts val="500"/>
+                <a:spcPts val="400"/>
               </a:spcAft>
             </a:pPr>
             <a:r>
-              <a:rPr b="1" sz="1250">
+              <a:rPr b="1" sz="1200">
                 <a:solidFill>
                   <a:srgbClr val="154360"/>
                 </a:solidFill>
@@ -8741,7 +9008,7 @@
               <a:t>Rural Connectivity Constraints: </a:t>
             </a:r>
             <a:r>
-              <a:rPr sz="1250">
+              <a:rPr sz="1200">
                 <a:solidFill>
                   <a:srgbClr val="2C3E50"/>
                 </a:solidFill>
@@ -8750,7 +9017,7 @@
               <a:t>Sub-Saharan rural farming belts face widespread cellular blind-spots, rendering cloud-dependent diagnostic APIs unusable.</a:t>
             </a:r>
             <a:r>
-              <a:rPr sz="1100" i="1">
+              <a:rPr sz="1050" i="1">
                 <a:solidFill>
                   <a:srgbClr val="B46E00"/>
                 </a:solidFill>
@@ -8765,11 +9032,11 @@
                 <a:spcPts val="200"/>
               </a:spcBef>
               <a:spcAft>
-                <a:spcPts val="500"/>
+                <a:spcPts val="400"/>
               </a:spcAft>
             </a:pPr>
             <a:r>
-              <a:rPr b="1" sz="1250">
+              <a:rPr b="1" sz="1200">
                 <a:solidFill>
                   <a:srgbClr val="154360"/>
                 </a:solidFill>
@@ -8778,7 +9045,7 @@
               <a:t>Fragmented Actionable Remedies: </a:t>
             </a:r>
             <a:r>
-              <a:rPr sz="1250">
+              <a:rPr sz="1200">
                 <a:solidFill>
                   <a:srgbClr val="2C3E50"/>
                 </a:solidFill>
@@ -8787,7 +9054,7 @@
               <a:t>Existing diagnostic tools identify pathologies without embedding localized, actionable chemical and organic treatment protocols.</a:t>
             </a:r>
             <a:r>
-              <a:rPr sz="1100" i="1">
+              <a:rPr sz="1050" i="1">
                 <a:solidFill>
                   <a:srgbClr val="B46E00"/>
                 </a:solidFill>
@@ -8989,26 +9256,26 @@
                 <a:spcPts val="200"/>
               </a:spcBef>
               <a:spcAft>
-                <a:spcPts val="500"/>
+                <a:spcPts val="400"/>
               </a:spcAft>
             </a:pPr>
             <a:r>
-              <a:rPr b="1" sz="1350">
+              <a:rPr b="1" sz="1150">
                 <a:solidFill>
                   <a:srgbClr val="154360"/>
                 </a:solidFill>
                 <a:latin typeface="Calibri"/>
               </a:rPr>
-              <a:t>General Objective: </a:t>
-            </a:r>
-            <a:r>
-              <a:rPr sz="1350">
+              <a:t>General Objective (Scientific AI Research): </a:t>
+            </a:r>
+            <a:r>
+              <a:rPr sz="1150">
                 <a:solidFill>
                   <a:srgbClr val="2C3E50"/>
                 </a:solidFill>
                 <a:latin typeface="Calibri"/>
               </a:rPr>
-              <a:t>To design, develop, optimize, and validate a real-time, offline, mobile-based crop disease detection and localized advisory system for Tomato and Maize crops.</a:t>
+              <a:t>Design, train, optimize, and empirically validate an attention-enhanced, INT8-quantized deep learning model with visual Grad-CAM explainability for accurate 14-class Tomato and Maize pathology diagnosis.</a:t>
             </a:r>
             <a:endParaRPr lang="en-GH" dirty="0">
               <a:latin typeface="Comic Sans MS" panose="030F0702030302020204" pitchFamily="66" charset="0"/>
@@ -9020,26 +9287,26 @@
                 <a:spcPts val="200"/>
               </a:spcBef>
               <a:spcAft>
-                <a:spcPts val="500"/>
+                <a:spcPts val="400"/>
               </a:spcAft>
             </a:pPr>
             <a:r>
-              <a:rPr b="1" sz="1300">
+              <a:rPr b="1" sz="1150">
                 <a:solidFill>
                   <a:srgbClr val="154360"/>
                 </a:solidFill>
                 <a:latin typeface="Calibri"/>
               </a:rPr>
-              <a:t>Specific Objective 1: </a:t>
-            </a:r>
-            <a:r>
-              <a:rPr sz="1300">
+              <a:t>General Objective (Mobile Model Integration): </a:t>
+            </a:r>
+            <a:r>
+              <a:rPr sz="1150">
                 <a:solidFill>
                   <a:srgbClr val="2C3E50"/>
                 </a:solidFill>
                 <a:latin typeface="Calibri"/>
               </a:rPr>
-              <a:t>Train a lightweight EfficientNet-B0 backbone fused with Triplet Attention across 14 Tomato and Maize classes.</a:t>
+              <a:t>Engineer and deploy a cross-platform, 100% offline Flutter mobile application embedding the lightweight on-device inference runtime paired with a local SQLite agronomic treatment database.</a:t>
             </a:r>
           </a:p>
           <a:p>
@@ -9048,26 +9315,26 @@
                 <a:spcPts val="200"/>
               </a:spcBef>
               <a:spcAft>
-                <a:spcPts val="500"/>
+                <a:spcPts val="400"/>
               </a:spcAft>
             </a:pPr>
             <a:r>
-              <a:rPr b="1" sz="1300">
+              <a:rPr b="1" sz="1100">
                 <a:solidFill>
                   <a:srgbClr val="154360"/>
                 </a:solidFill>
                 <a:latin typeface="Calibri"/>
               </a:rPr>
-              <a:t>Specific Objective 2: </a:t>
-            </a:r>
-            <a:r>
-              <a:rPr sz="1300">
+              <a:t>Specific Objective 1 (Model Architecture): </a:t>
+            </a:r>
+            <a:r>
+              <a:rPr sz="1100">
                 <a:solidFill>
                   <a:srgbClr val="2C3E50"/>
                 </a:solidFill>
                 <a:latin typeface="Calibri"/>
               </a:rPr>
-              <a:t>Quantize the model using INT8 Post-Training Quantization to achieve &lt;10 MB footprint and &lt;100 ms mobile latency.</a:t>
+              <a:t>Train an EfficientNet-B0 backbone fused with a 3-branch Triplet Attention mechanism across 14 Tomato &amp; Maize categories.</a:t>
             </a:r>
           </a:p>
           <a:p>
@@ -9076,26 +9343,26 @@
                 <a:spcPts val="200"/>
               </a:spcBef>
               <a:spcAft>
-                <a:spcPts val="500"/>
+                <a:spcPts val="400"/>
               </a:spcAft>
             </a:pPr>
             <a:r>
-              <a:rPr b="1" sz="1300">
+              <a:rPr b="1" sz="1100">
                 <a:solidFill>
                   <a:srgbClr val="154360"/>
                 </a:solidFill>
                 <a:latin typeface="Calibri"/>
               </a:rPr>
-              <a:t>Specific Objective 3: </a:t>
-            </a:r>
-            <a:r>
-              <a:rPr sz="1300">
+              <a:t>Specific Objective 2 (Edge Quantization): </a:t>
+            </a:r>
+            <a:r>
+              <a:rPr sz="1100">
                 <a:solidFill>
                   <a:srgbClr val="2C3E50"/>
                 </a:solidFill>
                 <a:latin typeface="Calibri"/>
               </a:rPr>
-              <a:t>Integrate Gradient-weighted Class Activation Mapping (Grad-CAM) to generate transparent visual diagnostic heatmaps.</a:t>
+              <a:t>Quantize the deep network using INT8 Post-Training Quantization to achieve &lt;10 MB footprint and &lt;100 ms mobile latency.</a:t>
             </a:r>
           </a:p>
           <a:p>
@@ -9104,26 +9371,26 @@
                 <a:spcPts val="200"/>
               </a:spcBef>
               <a:spcAft>
-                <a:spcPts val="500"/>
+                <a:spcPts val="400"/>
               </a:spcAft>
             </a:pPr>
             <a:r>
-              <a:rPr b="1" sz="1300">
+              <a:rPr b="1" sz="1100">
                 <a:solidFill>
                   <a:srgbClr val="154360"/>
                 </a:solidFill>
                 <a:latin typeface="Calibri"/>
               </a:rPr>
-              <a:t>Specific Objective 4: </a:t>
-            </a:r>
-            <a:r>
-              <a:rPr sz="1300">
+              <a:t>Specific Objective 3 (Explainability Layer): </a:t>
+            </a:r>
+            <a:r>
+              <a:rPr sz="1100">
                 <a:solidFill>
                   <a:srgbClr val="2C3E50"/>
                 </a:solidFill>
                 <a:latin typeface="Calibri"/>
               </a:rPr>
-              <a:t>Build a cross-platform Flutter mobile application with an embedded offline SQLite disease and treatment repository.</a:t>
+              <a:t>Embed Grad-CAM visual heatmaps for transparent, verified crop pathology decision-making directly on-device.</a:t>
             </a:r>
           </a:p>
           <a:p>
@@ -9132,26 +9399,54 @@
                 <a:spcPts val="200"/>
               </a:spcBef>
               <a:spcAft>
-                <a:spcPts val="500"/>
+                <a:spcPts val="400"/>
               </a:spcAft>
             </a:pPr>
             <a:r>
-              <a:rPr b="1" sz="1300">
+              <a:rPr b="1" sz="1100">
                 <a:solidFill>
                   <a:srgbClr val="154360"/>
                 </a:solidFill>
                 <a:latin typeface="Calibri"/>
               </a:rPr>
-              <a:t>Specific Objective 5: </a:t>
-            </a:r>
-            <a:r>
-              <a:rPr sz="1300">
+              <a:t>Specific Objective 4 (Mobile &amp; SQLite Integration): </a:t>
+            </a:r>
+            <a:r>
+              <a:rPr sz="1100">
                 <a:solidFill>
                   <a:srgbClr val="2C3E50"/>
                 </a:solidFill>
                 <a:latin typeface="Calibri"/>
               </a:rPr>
-              <a:t>Empirically evaluate real-world usability and user acceptance using the standard System Usability Scale (SUS).</a:t>
+              <a:t>Build a cross-platform Flutter application with an embedded offline SQLite disease dictionary and treatment protocol repository.</a:t>
+            </a:r>
+          </a:p>
+          <a:p>
+            <a:pPr>
+              <a:spcBef>
+                <a:spcPts val="200"/>
+              </a:spcBef>
+              <a:spcAft>
+                <a:spcPts val="400"/>
+              </a:spcAft>
+            </a:pPr>
+            <a:r>
+              <a:rPr b="1" sz="1100">
+                <a:solidFill>
+                  <a:srgbClr val="154360"/>
+                </a:solidFill>
+                <a:latin typeface="Calibri"/>
+              </a:rPr>
+              <a:t>Specific Objective 5 (Field Usability Evaluation): </a:t>
+            </a:r>
+            <a:r>
+              <a:rPr sz="1100">
+                <a:solidFill>
+                  <a:srgbClr val="2C3E50"/>
+                </a:solidFill>
+                <a:latin typeface="Calibri"/>
+              </a:rPr>
+              <a:t>Empirically evaluate real-world usability and farmer acceptance using the System Usability Scale (SUS).</a:t>
             </a:r>
           </a:p>
         </p:txBody>
@@ -9351,7 +9646,7 @@
                 <a:spcPts val="200"/>
               </a:spcBef>
               <a:spcAft>
-                <a:spcPts val="500"/>
+                <a:spcPts val="400"/>
               </a:spcAft>
             </a:pPr>
             <a:r>
@@ -9382,7 +9677,7 @@
                 <a:spcPts val="200"/>
               </a:spcBef>
               <a:spcAft>
-                <a:spcPts val="500"/>
+                <a:spcPts val="400"/>
               </a:spcAft>
             </a:pPr>
             <a:r>
@@ -9410,7 +9705,7 @@
                 <a:spcPts val="200"/>
               </a:spcBef>
               <a:spcAft>
-                <a:spcPts val="500"/>
+                <a:spcPts val="400"/>
               </a:spcAft>
             </a:pPr>
             <a:r>
@@ -9438,7 +9733,7 @@
                 <a:spcPts val="200"/>
               </a:spcBef>
               <a:spcAft>
-                <a:spcPts val="500"/>
+                <a:spcPts val="400"/>
               </a:spcAft>
             </a:pPr>
             <a:r>
@@ -9466,7 +9761,7 @@
                 <a:spcPts val="200"/>
               </a:spcBef>
               <a:spcAft>
-                <a:spcPts val="500"/>
+                <a:spcPts val="400"/>
               </a:spcAft>
             </a:pPr>
             <a:r>
@@ -9503,7 +9798,7 @@
                 <a:spcPts val="200"/>
               </a:spcBef>
               <a:spcAft>
-                <a:spcPts val="500"/>
+                <a:spcPts val="400"/>
               </a:spcAft>
             </a:pPr>
             <a:r>
@@ -9921,6 +10216,30 @@
           </a:prstGeom>
         </p:spPr>
       </p:pic>
+      <p:pic>
+        <p:nvPicPr>
+          <p:cNvPr id="10" name="Picture 9" descr="image.png"/>
+          <p:cNvPicPr>
+            <a:picLocks noChangeAspect="1"/>
+          </p:cNvPicPr>
+          <p:nvPr/>
+        </p:nvPicPr>
+        <p:blipFill>
+          <a:blip r:embed="rId3"/>
+          <a:stretch>
+            <a:fillRect/>
+          </a:stretch>
+        </p:blipFill>
+        <p:spPr>
+          <a:xfrm>
+            <a:off x="777240" y="1005840"/>
+            <a:ext cx="7589520" cy="5029200"/>
+          </a:xfrm>
+          <a:prstGeom prst="rect">
+            <a:avLst/>
+          </a:prstGeom>
+        </p:spPr>
+      </p:pic>
     </p:spTree>
     <p:extLst>
       <p:ext uri="{BB962C8B-B14F-4D97-AF65-F5344CB8AC3E}">
@@ -10023,7 +10342,7 @@
                 <a:spcPts val="200"/>
               </a:spcBef>
               <a:spcAft>
-                <a:spcPts val="500"/>
+                <a:spcPts val="400"/>
               </a:spcAft>
             </a:pPr>
             <a:r>
@@ -10042,7 +10361,7 @@
                 </a:solidFill>
                 <a:latin typeface="Calibri"/>
               </a:rPr>
-              <a:t>21,394 expert-verified leaf photographs covering 14 distinct crop health categories.</a:t>
+              <a:t>21,394 expert-annotated leaf photographs across 14 categories.</a:t>
             </a:r>
             <a:r>
               <a:rPr sz="1150" i="1">
@@ -10063,7 +10382,7 @@
                 <a:spcPts val="200"/>
               </a:spcBef>
               <a:spcAft>
-                <a:spcPts val="500"/>
+                <a:spcPts val="400"/>
               </a:spcAft>
             </a:pPr>
             <a:r>
@@ -10091,7 +10410,7 @@
                 <a:spcPts val="200"/>
               </a:spcBef>
               <a:spcAft>
-                <a:spcPts val="500"/>
+                <a:spcPts val="400"/>
               </a:spcAft>
             </a:pPr>
             <a:r>
@@ -10119,7 +10438,7 @@
                 <a:spcPts val="200"/>
               </a:spcBef>
               <a:spcAft>
-                <a:spcPts val="500"/>
+                <a:spcPts val="400"/>
               </a:spcAft>
             </a:pPr>
             <a:r>
@@ -10147,7 +10466,7 @@
                 <a:spcPts val="200"/>
               </a:spcBef>
               <a:spcAft>
-                <a:spcPts val="500"/>
+                <a:spcPts val="400"/>
               </a:spcAft>
             </a:pPr>
             <a:r>
@@ -10540,6 +10859,30 @@
           </a:prstGeom>
         </p:spPr>
       </p:pic>
+      <p:pic>
+        <p:nvPicPr>
+          <p:cNvPr id="9" name="Picture 8" descr="image.png"/>
+          <p:cNvPicPr>
+            <a:picLocks noChangeAspect="1"/>
+          </p:cNvPicPr>
+          <p:nvPr/>
+        </p:nvPicPr>
+        <p:blipFill>
+          <a:blip r:embed="rId2"/>
+          <a:stretch>
+            <a:fillRect/>
+          </a:stretch>
+        </p:blipFill>
+        <p:spPr>
+          <a:xfrm>
+            <a:off x="777240" y="1005840"/>
+            <a:ext cx="7589520" cy="5029200"/>
+          </a:xfrm>
+          <a:prstGeom prst="rect">
+            <a:avLst/>
+          </a:prstGeom>
+        </p:spPr>
+      </p:pic>
     </p:spTree>
     <p:extLst>
       <p:ext uri="{BB962C8B-B14F-4D97-AF65-F5344CB8AC3E}">
@@ -10642,7 +10985,7 @@
                 <a:spcPts val="200"/>
               </a:spcBef>
               <a:spcAft>
-                <a:spcPts val="500"/>
+                <a:spcPts val="400"/>
               </a:spcAft>
             </a:pPr>
             <a:r>
@@ -10682,7 +11025,7 @@
                 <a:spcPts val="200"/>
               </a:spcBef>
               <a:spcAft>
-                <a:spcPts val="500"/>
+                <a:spcPts val="400"/>
               </a:spcAft>
             </a:pPr>
             <a:r>
@@ -10719,7 +11062,7 @@
                 <a:spcPts val="200"/>
               </a:spcBef>
               <a:spcAft>
-                <a:spcPts val="500"/>
+                <a:spcPts val="400"/>
               </a:spcAft>
             </a:pPr>
             <a:r>
@@ -10747,7 +11090,7 @@
                 <a:spcPts val="200"/>
               </a:spcBef>
               <a:spcAft>
-                <a:spcPts val="500"/>
+                <a:spcPts val="400"/>
               </a:spcAft>
             </a:pPr>
             <a:r>
@@ -10775,7 +11118,7 @@
                 <a:spcPts val="200"/>
               </a:spcBef>
               <a:spcAft>
-                <a:spcPts val="500"/>
+                <a:spcPts val="400"/>
               </a:spcAft>
             </a:pPr>
             <a:r>
@@ -10803,7 +11146,7 @@
                 <a:spcPts val="200"/>
               </a:spcBef>
               <a:spcAft>
-                <a:spcPts val="500"/>
+                <a:spcPts val="400"/>
               </a:spcAft>
             </a:pPr>
             <a:r>

</xml_diff>

<commit_message>
Embed native styled Dataset & Augmentation Pipeline table on Slide 7 of presentation
</commit_message>
<xml_diff>
--- a/Power Point Templete.pptx
+++ b/Power Point Templete.pptx
@@ -10330,6 +10330,7 @@
         </p:nvSpPr>
         <p:spPr>
           <a:xfrm>
+            <a:off x="9144000" y="0"/>
             <a:ext cx="4114800" cy="0"/>
           </a:xfrm>
         </p:spPr>
@@ -10345,148 +10346,9 @@
                 <a:spcPts val="400"/>
               </a:spcAft>
             </a:pPr>
-            <a:r>
-              <a:rPr b="1" sz="1300">
-                <a:solidFill>
-                  <a:srgbClr val="154360"/>
-                </a:solidFill>
-                <a:latin typeface="Calibri"/>
-              </a:rPr>
-              <a:t>PlantVillage Benchmark Dataset: </a:t>
-            </a:r>
-            <a:r>
-              <a:rPr sz="1300">
-                <a:solidFill>
-                  <a:srgbClr val="2C3E50"/>
-                </a:solidFill>
-                <a:latin typeface="Calibri"/>
-              </a:rPr>
-              <a:t>21,394 expert-annotated leaf photographs across 14 categories.</a:t>
-            </a:r>
-            <a:r>
-              <a:rPr sz="1150" i="1">
-                <a:solidFill>
-                  <a:srgbClr val="B46E00"/>
-                </a:solidFill>
-                <a:latin typeface="Calibri"/>
-              </a:rPr>
-              <a:t> (Hughes &amp; Salathe, 2015)</a:t>
-            </a:r>
             <a:endParaRPr lang="en-GH" dirty="0">
               <a:latin typeface="Comic Sans MS" panose="030F0702030302020204" pitchFamily="66" charset="0"/>
             </a:endParaRPr>
-          </a:p>
-          <a:p>
-            <a:pPr>
-              <a:spcBef>
-                <a:spcPts val="200"/>
-              </a:spcBef>
-              <a:spcAft>
-                <a:spcPts val="400"/>
-              </a:spcAft>
-            </a:pPr>
-            <a:r>
-              <a:rPr b="1" sz="1250">
-                <a:solidFill>
-                  <a:srgbClr val="154360"/>
-                </a:solidFill>
-                <a:latin typeface="Calibri"/>
-              </a:rPr>
-              <a:t>4 Maize Classes (3,852 images): </a:t>
-            </a:r>
-            <a:r>
-              <a:rPr sz="1250">
-                <a:solidFill>
-                  <a:srgbClr val="2C3E50"/>
-                </a:solidFill>
-                <a:latin typeface="Calibri"/>
-              </a:rPr>
-              <a:t>Cercospora Gray Leaf Spot (513), Common Rust (1,192), Northern Leaf Blight (985), Healthy Maize (1,162).</a:t>
-            </a:r>
-          </a:p>
-          <a:p>
-            <a:pPr>
-              <a:spcBef>
-                <a:spcPts val="200"/>
-              </a:spcBef>
-              <a:spcAft>
-                <a:spcPts val="400"/>
-              </a:spcAft>
-            </a:pPr>
-            <a:r>
-              <a:rPr b="1" sz="1200">
-                <a:solidFill>
-                  <a:srgbClr val="154360"/>
-                </a:solidFill>
-                <a:latin typeface="Calibri"/>
-              </a:rPr>
-              <a:t>10 Tomato Classes (17,542 images): </a:t>
-            </a:r>
-            <a:r>
-              <a:rPr sz="1200">
-                <a:solidFill>
-                  <a:srgbClr val="2C3E50"/>
-                </a:solidFill>
-                <a:latin typeface="Calibri"/>
-              </a:rPr>
-              <a:t>Bacterial Spot (2,127), Early Blight (1,000), Late Blight (1,909), Leaf Mold (952), Septoria (1,771), Spider Mites (1,676), Target Spot (1,404), Yellow Leaf Curl (3,209), Mosaic Virus (373), Healthy (1,591).</a:t>
-            </a:r>
-          </a:p>
-          <a:p>
-            <a:pPr>
-              <a:spcBef>
-                <a:spcPts val="200"/>
-              </a:spcBef>
-              <a:spcAft>
-                <a:spcPts val="400"/>
-              </a:spcAft>
-            </a:pPr>
-            <a:r>
-              <a:rPr b="1" sz="1300">
-                <a:solidFill>
-                  <a:srgbClr val="154360"/>
-                </a:solidFill>
-                <a:latin typeface="Calibri"/>
-              </a:rPr>
-              <a:t>Stratified Data Splitting: </a:t>
-            </a:r>
-            <a:r>
-              <a:rPr sz="1300">
-                <a:solidFill>
-                  <a:srgbClr val="2C3E50"/>
-                </a:solidFill>
-                <a:latin typeface="Calibri"/>
-              </a:rPr>
-              <a:t>70% Training (14,976 images), 15% Validation (3,209 images), 15% Held-out Test (3,209 images).</a:t>
-            </a:r>
-          </a:p>
-          <a:p>
-            <a:pPr>
-              <a:spcBef>
-                <a:spcPts val="200"/>
-              </a:spcBef>
-              <a:spcAft>
-                <a:spcPts val="400"/>
-              </a:spcAft>
-            </a:pPr>
-            <a:r>
-              <a:rPr b="1" sz="1300">
-                <a:solidFill>
-                  <a:srgbClr val="154360"/>
-                </a:solidFill>
-                <a:latin typeface="Calibri"/>
-              </a:rPr>
-              <a:t>Data Augmentation Parameters: </a:t>
-            </a:r>
-            <a:r>
-              <a:rPr sz="1300">
-                <a:solidFill>
-                  <a:srgbClr val="2C3E50"/>
-                </a:solidFill>
-                <a:latin typeface="Calibri"/>
-              </a:rPr>
-              <a:t>Random rotation (+/-30 deg), zoom (+/-20%), horizontal/vertical flips, and contrast shifts (+/-15%) to simulate field sunlight.</a:t>
-            </a:r>
           </a:p>
         </p:txBody>
       </p:sp>
@@ -10607,6 +10469,814 @@
           </a:prstGeom>
         </p:spPr>
       </p:pic>
+      <p:graphicFrame>
+        <p:nvGraphicFramePr>
+          <p:cNvPr id="8" name="Table 7"/>
+          <p:cNvGraphicFramePr>
+            <a:graphicFrameLocks noGrp="1"/>
+          </p:cNvGraphicFramePr>
+          <p:nvPr/>
+        </p:nvGraphicFramePr>
+        <p:xfrm>
+          <a:off x="640080" y="1097280"/>
+          <a:ext cx="7863840" cy="4846320"/>
+        </p:xfrm>
+        <a:graphic>
+          <a:graphicData uri="http://schemas.openxmlformats.org/drawingml/2006/table">
+            <a:tbl>
+              <a:tblPr firstRow="1" bandRow="1">
+                <a:tableStyleId>{5C22544A-7EE6-4342-B048-85BDC9FD1C3A}</a:tableStyleId>
+              </a:tblPr>
+              <a:tblGrid>
+                <a:gridCol w="2011680"/>
+                <a:gridCol w="1463040"/>
+                <a:gridCol w="4389120"/>
+              </a:tblGrid>
+              <a:tr h="440574">
+                <a:tc>
+                  <a:txBody>
+                    <a:bodyPr/>
+                    <a:lstStyle/>
+                    <a:p>
+                      <a:pPr algn="ctr"/>
+                      <a:r>
+                        <a:rPr sz="1050" b="1">
+                          <a:solidFill>
+                            <a:srgbClr val="FFFFFF"/>
+                          </a:solidFill>
+                          <a:latin typeface="Calibri"/>
+                        </a:rPr>
+                        <a:t>Augmentation Technique</a:t>
+                      </a:r>
+                    </a:p>
+                  </a:txBody>
+                  <a:tcPr>
+                    <a:solidFill>
+                      <a:srgbClr val="186A3B"/>
+                    </a:solidFill>
+                  </a:tcPr>
+                </a:tc>
+                <a:tc>
+                  <a:txBody>
+                    <a:bodyPr/>
+                    <a:lstStyle/>
+                    <a:p>
+                      <a:pPr algn="ctr"/>
+                      <a:r>
+                        <a:rPr sz="1050" b="1">
+                          <a:solidFill>
+                            <a:srgbClr val="FFFFFF"/>
+                          </a:solidFill>
+                          <a:latin typeface="Calibri"/>
+                        </a:rPr>
+                        <a:t>Parameter Value</a:t>
+                      </a:r>
+                    </a:p>
+                  </a:txBody>
+                  <a:tcPr>
+                    <a:solidFill>
+                      <a:srgbClr val="186A3B"/>
+                    </a:solidFill>
+                  </a:tcPr>
+                </a:tc>
+                <a:tc>
+                  <a:txBody>
+                    <a:bodyPr/>
+                    <a:lstStyle/>
+                    <a:p>
+                      <a:pPr algn="l"/>
+                      <a:r>
+                        <a:rPr sz="1050" b="1">
+                          <a:solidFill>
+                            <a:srgbClr val="FFFFFF"/>
+                          </a:solidFill>
+                          <a:latin typeface="Calibri"/>
+                        </a:rPr>
+                        <a:t>Technical &amp; Agronomic Rationale</a:t>
+                      </a:r>
+                    </a:p>
+                  </a:txBody>
+                  <a:tcPr>
+                    <a:solidFill>
+                      <a:srgbClr val="186A3B"/>
+                    </a:solidFill>
+                  </a:tcPr>
+                </a:tc>
+              </a:tr>
+              <a:tr h="440574">
+                <a:tc>
+                  <a:txBody>
+                    <a:bodyPr/>
+                    <a:lstStyle/>
+                    <a:p>
+                      <a:pPr algn="l"/>
+                      <a:r>
+                        <a:rPr sz="950" b="1">
+                          <a:solidFill>
+                            <a:srgbClr val="154360"/>
+                          </a:solidFill>
+                          <a:latin typeface="Calibri"/>
+                        </a:rPr>
+                        <a:t>Random Rotation</a:t>
+                      </a:r>
+                    </a:p>
+                  </a:txBody>
+                  <a:tcPr>
+                    <a:solidFill>
+                      <a:srgbClr val="F5F8FA"/>
+                    </a:solidFill>
+                  </a:tcPr>
+                </a:tc>
+                <a:tc>
+                  <a:txBody>
+                    <a:bodyPr/>
+                    <a:lstStyle/>
+                    <a:p>
+                      <a:pPr algn="ctr"/>
+                      <a:r>
+                        <a:rPr sz="950" b="1">
+                          <a:solidFill>
+                            <a:srgbClr val="186A3B"/>
+                          </a:solidFill>
+                          <a:latin typeface="Calibri"/>
+                        </a:rPr>
+                        <a:t>±30°</a:t>
+                      </a:r>
+                    </a:p>
+                  </a:txBody>
+                  <a:tcPr>
+                    <a:solidFill>
+                      <a:srgbClr val="F5F8FA"/>
+                    </a:solidFill>
+                  </a:tcPr>
+                </a:tc>
+                <a:tc>
+                  <a:txBody>
+                    <a:bodyPr/>
+                    <a:lstStyle/>
+                    <a:p>
+                      <a:pPr algn="l"/>
+                      <a:r>
+                        <a:rPr sz="900" b="0">
+                          <a:solidFill>
+                            <a:srgbClr val="2C3E50"/>
+                          </a:solidFill>
+                          <a:latin typeface="Calibri"/>
+                        </a:rPr>
+                        <a:t>Simulates varied leaf angles relative to smartphone camera in field conditions.</a:t>
+                      </a:r>
+                    </a:p>
+                  </a:txBody>
+                  <a:tcPr>
+                    <a:solidFill>
+                      <a:srgbClr val="F5F8FA"/>
+                    </a:solidFill>
+                  </a:tcPr>
+                </a:tc>
+              </a:tr>
+              <a:tr h="440574">
+                <a:tc>
+                  <a:txBody>
+                    <a:bodyPr/>
+                    <a:lstStyle/>
+                    <a:p>
+                      <a:pPr algn="l"/>
+                      <a:r>
+                        <a:rPr sz="950" b="1">
+                          <a:solidFill>
+                            <a:srgbClr val="154360"/>
+                          </a:solidFill>
+                          <a:latin typeface="Calibri"/>
+                        </a:rPr>
+                        <a:t>Width Shift</a:t>
+                      </a:r>
+                    </a:p>
+                  </a:txBody>
+                  <a:tcPr>
+                    <a:solidFill>
+                      <a:srgbClr val="FFFFFF"/>
+                    </a:solidFill>
+                  </a:tcPr>
+                </a:tc>
+                <a:tc>
+                  <a:txBody>
+                    <a:bodyPr/>
+                    <a:lstStyle/>
+                    <a:p>
+                      <a:pPr algn="ctr"/>
+                      <a:r>
+                        <a:rPr sz="950" b="1">
+                          <a:solidFill>
+                            <a:srgbClr val="186A3B"/>
+                          </a:solidFill>
+                          <a:latin typeface="Calibri"/>
+                        </a:rPr>
+                        <a:t>±15%</a:t>
+                      </a:r>
+                    </a:p>
+                  </a:txBody>
+                  <a:tcPr>
+                    <a:solidFill>
+                      <a:srgbClr val="FFFFFF"/>
+                    </a:solidFill>
+                  </a:tcPr>
+                </a:tc>
+                <a:tc>
+                  <a:txBody>
+                    <a:bodyPr/>
+                    <a:lstStyle/>
+                    <a:p>
+                      <a:pPr algn="l"/>
+                      <a:r>
+                        <a:rPr sz="900" b="0">
+                          <a:solidFill>
+                            <a:srgbClr val="2C3E50"/>
+                          </a:solidFill>
+                          <a:latin typeface="Calibri"/>
+                        </a:rPr>
+                        <a:t>Handles off-centre leaf positioning within the camera viewfinder.</a:t>
+                      </a:r>
+                    </a:p>
+                  </a:txBody>
+                  <a:tcPr>
+                    <a:solidFill>
+                      <a:srgbClr val="FFFFFF"/>
+                    </a:solidFill>
+                  </a:tcPr>
+                </a:tc>
+              </a:tr>
+              <a:tr h="440574">
+                <a:tc>
+                  <a:txBody>
+                    <a:bodyPr/>
+                    <a:lstStyle/>
+                    <a:p>
+                      <a:pPr algn="l"/>
+                      <a:r>
+                        <a:rPr sz="950" b="1">
+                          <a:solidFill>
+                            <a:srgbClr val="154360"/>
+                          </a:solidFill>
+                          <a:latin typeface="Calibri"/>
+                        </a:rPr>
+                        <a:t>Height Shift</a:t>
+                      </a:r>
+                    </a:p>
+                  </a:txBody>
+                  <a:tcPr>
+                    <a:solidFill>
+                      <a:srgbClr val="F5F8FA"/>
+                    </a:solidFill>
+                  </a:tcPr>
+                </a:tc>
+                <a:tc>
+                  <a:txBody>
+                    <a:bodyPr/>
+                    <a:lstStyle/>
+                    <a:p>
+                      <a:pPr algn="ctr"/>
+                      <a:r>
+                        <a:rPr sz="950" b="1">
+                          <a:solidFill>
+                            <a:srgbClr val="186A3B"/>
+                          </a:solidFill>
+                          <a:latin typeface="Calibri"/>
+                        </a:rPr>
+                        <a:t>±15%</a:t>
+                      </a:r>
+                    </a:p>
+                  </a:txBody>
+                  <a:tcPr>
+                    <a:solidFill>
+                      <a:srgbClr val="F5F8FA"/>
+                    </a:solidFill>
+                  </a:tcPr>
+                </a:tc>
+                <a:tc>
+                  <a:txBody>
+                    <a:bodyPr/>
+                    <a:lstStyle/>
+                    <a:p>
+                      <a:pPr algn="l"/>
+                      <a:r>
+                        <a:rPr sz="900" b="0">
+                          <a:solidFill>
+                            <a:srgbClr val="2C3E50"/>
+                          </a:solidFill>
+                          <a:latin typeface="Calibri"/>
+                        </a:rPr>
+                        <a:t>Compensates for vertical framing variations during handheld farmer capture.</a:t>
+                      </a:r>
+                    </a:p>
+                  </a:txBody>
+                  <a:tcPr>
+                    <a:solidFill>
+                      <a:srgbClr val="F5F8FA"/>
+                    </a:solidFill>
+                  </a:tcPr>
+                </a:tc>
+              </a:tr>
+              <a:tr h="440574">
+                <a:tc>
+                  <a:txBody>
+                    <a:bodyPr/>
+                    <a:lstStyle/>
+                    <a:p>
+                      <a:pPr algn="l"/>
+                      <a:r>
+                        <a:rPr sz="950" b="1">
+                          <a:solidFill>
+                            <a:srgbClr val="154360"/>
+                          </a:solidFill>
+                          <a:latin typeface="Calibri"/>
+                        </a:rPr>
+                        <a:t>Shear Angle</a:t>
+                      </a:r>
+                    </a:p>
+                  </a:txBody>
+                  <a:tcPr>
+                    <a:solidFill>
+                      <a:srgbClr val="FFFFFF"/>
+                    </a:solidFill>
+                  </a:tcPr>
+                </a:tc>
+                <a:tc>
+                  <a:txBody>
+                    <a:bodyPr/>
+                    <a:lstStyle/>
+                    <a:p>
+                      <a:pPr algn="ctr"/>
+                      <a:r>
+                        <a:rPr sz="950" b="1">
+                          <a:solidFill>
+                            <a:srgbClr val="186A3B"/>
+                          </a:solidFill>
+                          <a:latin typeface="Calibri"/>
+                        </a:rPr>
+                        <a:t>±15%</a:t>
+                      </a:r>
+                    </a:p>
+                  </a:txBody>
+                  <a:tcPr>
+                    <a:solidFill>
+                      <a:srgbClr val="FFFFFF"/>
+                    </a:solidFill>
+                  </a:tcPr>
+                </a:tc>
+                <a:tc>
+                  <a:txBody>
+                    <a:bodyPr/>
+                    <a:lstStyle/>
+                    <a:p>
+                      <a:pPr algn="l"/>
+                      <a:r>
+                        <a:rPr sz="900" b="0">
+                          <a:solidFill>
+                            <a:srgbClr val="2C3E50"/>
+                          </a:solidFill>
+                          <a:latin typeface="Calibri"/>
+                        </a:rPr>
+                        <a:t>Simulates perspective distortion caused by oblique camera tilting.</a:t>
+                      </a:r>
+                    </a:p>
+                  </a:txBody>
+                  <a:tcPr>
+                    <a:solidFill>
+                      <a:srgbClr val="FFFFFF"/>
+                    </a:solidFill>
+                  </a:tcPr>
+                </a:tc>
+              </a:tr>
+              <a:tr h="440574">
+                <a:tc>
+                  <a:txBody>
+                    <a:bodyPr/>
+                    <a:lstStyle/>
+                    <a:p>
+                      <a:pPr algn="l"/>
+                      <a:r>
+                        <a:rPr sz="950" b="1">
+                          <a:solidFill>
+                            <a:srgbClr val="154360"/>
+                          </a:solidFill>
+                          <a:latin typeface="Calibri"/>
+                        </a:rPr>
+                        <a:t>Random Zoom</a:t>
+                      </a:r>
+                    </a:p>
+                  </a:txBody>
+                  <a:tcPr>
+                    <a:solidFill>
+                      <a:srgbClr val="F5F8FA"/>
+                    </a:solidFill>
+                  </a:tcPr>
+                </a:tc>
+                <a:tc>
+                  <a:txBody>
+                    <a:bodyPr/>
+                    <a:lstStyle/>
+                    <a:p>
+                      <a:pPr algn="ctr"/>
+                      <a:r>
+                        <a:rPr sz="950" b="1">
+                          <a:solidFill>
+                            <a:srgbClr val="186A3B"/>
+                          </a:solidFill>
+                          <a:latin typeface="Calibri"/>
+                        </a:rPr>
+                        <a:t>±20%</a:t>
+                      </a:r>
+                    </a:p>
+                  </a:txBody>
+                  <a:tcPr>
+                    <a:solidFill>
+                      <a:srgbClr val="F5F8FA"/>
+                    </a:solidFill>
+                  </a:tcPr>
+                </a:tc>
+                <a:tc>
+                  <a:txBody>
+                    <a:bodyPr/>
+                    <a:lstStyle/>
+                    <a:p>
+                      <a:pPr algn="l"/>
+                      <a:r>
+                        <a:rPr sz="900" b="0">
+                          <a:solidFill>
+                            <a:srgbClr val="2C3E50"/>
+                          </a:solidFill>
+                          <a:latin typeface="Calibri"/>
+                        </a:rPr>
+                        <a:t>Replicates varying handheld distances from leaf surface to camera lens.</a:t>
+                      </a:r>
+                    </a:p>
+                  </a:txBody>
+                  <a:tcPr>
+                    <a:solidFill>
+                      <a:srgbClr val="F5F8FA"/>
+                    </a:solidFill>
+                  </a:tcPr>
+                </a:tc>
+              </a:tr>
+              <a:tr h="440574">
+                <a:tc>
+                  <a:txBody>
+                    <a:bodyPr/>
+                    <a:lstStyle/>
+                    <a:p>
+                      <a:pPr algn="l"/>
+                      <a:r>
+                        <a:rPr sz="950" b="1">
+                          <a:solidFill>
+                            <a:srgbClr val="154360"/>
+                          </a:solidFill>
+                          <a:latin typeface="Calibri"/>
+                        </a:rPr>
+                        <a:t>Horizontal Flip</a:t>
+                      </a:r>
+                    </a:p>
+                  </a:txBody>
+                  <a:tcPr>
+                    <a:solidFill>
+                      <a:srgbClr val="FFFFFF"/>
+                    </a:solidFill>
+                  </a:tcPr>
+                </a:tc>
+                <a:tc>
+                  <a:txBody>
+                    <a:bodyPr/>
+                    <a:lstStyle/>
+                    <a:p>
+                      <a:pPr algn="ctr"/>
+                      <a:r>
+                        <a:rPr sz="950" b="1">
+                          <a:solidFill>
+                            <a:srgbClr val="186A3B"/>
+                          </a:solidFill>
+                          <a:latin typeface="Calibri"/>
+                        </a:rPr>
+                        <a:t>Enabled (50%)</a:t>
+                      </a:r>
+                    </a:p>
+                  </a:txBody>
+                  <a:tcPr>
+                    <a:solidFill>
+                      <a:srgbClr val="FFFFFF"/>
+                    </a:solidFill>
+                  </a:tcPr>
+                </a:tc>
+                <a:tc>
+                  <a:txBody>
+                    <a:bodyPr/>
+                    <a:lstStyle/>
+                    <a:p>
+                      <a:pPr algn="l"/>
+                      <a:r>
+                        <a:rPr sz="900" b="0">
+                          <a:solidFill>
+                            <a:srgbClr val="2C3E50"/>
+                          </a:solidFill>
+                          <a:latin typeface="Calibri"/>
+                        </a:rPr>
+                        <a:t>Leaf disease symptom patterns exhibit vertical bilateral symmetry.</a:t>
+                      </a:r>
+                    </a:p>
+                  </a:txBody>
+                  <a:tcPr>
+                    <a:solidFill>
+                      <a:srgbClr val="FFFFFF"/>
+                    </a:solidFill>
+                  </a:tcPr>
+                </a:tc>
+              </a:tr>
+              <a:tr h="440574">
+                <a:tc>
+                  <a:txBody>
+                    <a:bodyPr/>
+                    <a:lstStyle/>
+                    <a:p>
+                      <a:pPr algn="l"/>
+                      <a:r>
+                        <a:rPr sz="950" b="1">
+                          <a:solidFill>
+                            <a:srgbClr val="154360"/>
+                          </a:solidFill>
+                          <a:latin typeface="Calibri"/>
+                        </a:rPr>
+                        <a:t>Vertical Flip</a:t>
+                      </a:r>
+                    </a:p>
+                  </a:txBody>
+                  <a:tcPr>
+                    <a:solidFill>
+                      <a:srgbClr val="F5F8FA"/>
+                    </a:solidFill>
+                  </a:tcPr>
+                </a:tc>
+                <a:tc>
+                  <a:txBody>
+                    <a:bodyPr/>
+                    <a:lstStyle/>
+                    <a:p>
+                      <a:pPr algn="ctr"/>
+                      <a:r>
+                        <a:rPr sz="950" b="1">
+                          <a:solidFill>
+                            <a:srgbClr val="186A3B"/>
+                          </a:solidFill>
+                          <a:latin typeface="Calibri"/>
+                        </a:rPr>
+                        <a:t>Enabled (50%)</a:t>
+                      </a:r>
+                    </a:p>
+                  </a:txBody>
+                  <a:tcPr>
+                    <a:solidFill>
+                      <a:srgbClr val="F5F8FA"/>
+                    </a:solidFill>
+                  </a:tcPr>
+                </a:tc>
+                <a:tc>
+                  <a:txBody>
+                    <a:bodyPr/>
+                    <a:lstStyle/>
+                    <a:p>
+                      <a:pPr algn="l"/>
+                      <a:r>
+                        <a:rPr sz="900" b="0">
+                          <a:solidFill>
+                            <a:srgbClr val="2C3E50"/>
+                          </a:solidFill>
+                          <a:latin typeface="Calibri"/>
+                        </a:rPr>
+                        <a:t>Accounts for inverted or downward-hanging leaves on crop canopies.</a:t>
+                      </a:r>
+                    </a:p>
+                  </a:txBody>
+                  <a:tcPr>
+                    <a:solidFill>
+                      <a:srgbClr val="F5F8FA"/>
+                    </a:solidFill>
+                  </a:tcPr>
+                </a:tc>
+              </a:tr>
+              <a:tr h="440574">
+                <a:tc>
+                  <a:txBody>
+                    <a:bodyPr/>
+                    <a:lstStyle/>
+                    <a:p>
+                      <a:pPr algn="l"/>
+                      <a:r>
+                        <a:rPr sz="950" b="1">
+                          <a:solidFill>
+                            <a:srgbClr val="154360"/>
+                          </a:solidFill>
+                          <a:latin typeface="Calibri"/>
+                        </a:rPr>
+                        <a:t>Brightness Range</a:t>
+                      </a:r>
+                    </a:p>
+                  </a:txBody>
+                  <a:tcPr>
+                    <a:solidFill>
+                      <a:srgbClr val="FFFFFF"/>
+                    </a:solidFill>
+                  </a:tcPr>
+                </a:tc>
+                <a:tc>
+                  <a:txBody>
+                    <a:bodyPr/>
+                    <a:lstStyle/>
+                    <a:p>
+                      <a:pPr algn="ctr"/>
+                      <a:r>
+                        <a:rPr sz="950" b="1">
+                          <a:solidFill>
+                            <a:srgbClr val="186A3B"/>
+                          </a:solidFill>
+                          <a:latin typeface="Calibri"/>
+                        </a:rPr>
+                        <a:t>[0.7 – 1.3]</a:t>
+                      </a:r>
+                    </a:p>
+                  </a:txBody>
+                  <a:tcPr>
+                    <a:solidFill>
+                      <a:srgbClr val="FFFFFF"/>
+                    </a:solidFill>
+                  </a:tcPr>
+                </a:tc>
+                <a:tc>
+                  <a:txBody>
+                    <a:bodyPr/>
+                    <a:lstStyle/>
+                    <a:p>
+                      <a:pPr algn="l"/>
+                      <a:r>
+                        <a:rPr sz="900" b="0">
+                          <a:solidFill>
+                            <a:srgbClr val="2C3E50"/>
+                          </a:solidFill>
+                          <a:latin typeface="Calibri"/>
+                        </a:rPr>
+                        <a:t>Simulates variable outdoor solar illumination (direct sunlight to heavy overcast).</a:t>
+                      </a:r>
+                    </a:p>
+                  </a:txBody>
+                  <a:tcPr>
+                    <a:solidFill>
+                      <a:srgbClr val="FFFFFF"/>
+                    </a:solidFill>
+                  </a:tcPr>
+                </a:tc>
+              </a:tr>
+              <a:tr h="440574">
+                <a:tc>
+                  <a:txBody>
+                    <a:bodyPr/>
+                    <a:lstStyle/>
+                    <a:p>
+                      <a:pPr algn="l"/>
+                      <a:r>
+                        <a:rPr sz="950" b="1">
+                          <a:solidFill>
+                            <a:srgbClr val="154360"/>
+                          </a:solidFill>
+                          <a:latin typeface="Calibri"/>
+                        </a:rPr>
+                        <a:t>Channel Shift</a:t>
+                      </a:r>
+                    </a:p>
+                  </a:txBody>
+                  <a:tcPr>
+                    <a:solidFill>
+                      <a:srgbClr val="F5F8FA"/>
+                    </a:solidFill>
+                  </a:tcPr>
+                </a:tc>
+                <a:tc>
+                  <a:txBody>
+                    <a:bodyPr/>
+                    <a:lstStyle/>
+                    <a:p>
+                      <a:pPr algn="ctr"/>
+                      <a:r>
+                        <a:rPr sz="950" b="1">
+                          <a:solidFill>
+                            <a:srgbClr val="186A3B"/>
+                          </a:solidFill>
+                          <a:latin typeface="Calibri"/>
+                        </a:rPr>
+                        <a:t>±25.0</a:t>
+                      </a:r>
+                    </a:p>
+                  </a:txBody>
+                  <a:tcPr>
+                    <a:solidFill>
+                      <a:srgbClr val="F5F8FA"/>
+                    </a:solidFill>
+                  </a:tcPr>
+                </a:tc>
+                <a:tc>
+                  <a:txBody>
+                    <a:bodyPr/>
+                    <a:lstStyle/>
+                    <a:p>
+                      <a:pPr algn="l"/>
+                      <a:r>
+                        <a:rPr sz="900" b="0">
+                          <a:solidFill>
+                            <a:srgbClr val="2C3E50"/>
+                          </a:solidFill>
+                          <a:latin typeface="Calibri"/>
+                        </a:rPr>
+                        <a:t>Models sensor color balance variations across budget smartphone models.</a:t>
+                      </a:r>
+                    </a:p>
+                  </a:txBody>
+                  <a:tcPr>
+                    <a:solidFill>
+                      <a:srgbClr val="F5F8FA"/>
+                    </a:solidFill>
+                  </a:tcPr>
+                </a:tc>
+              </a:tr>
+              <a:tr h="440580">
+                <a:tc>
+                  <a:txBody>
+                    <a:bodyPr/>
+                    <a:lstStyle/>
+                    <a:p>
+                      <a:pPr algn="l"/>
+                      <a:r>
+                        <a:rPr sz="950" b="1">
+                          <a:solidFill>
+                            <a:srgbClr val="154360"/>
+                          </a:solidFill>
+                          <a:latin typeface="Calibri"/>
+                        </a:rPr>
+                        <a:t>Fill Mode</a:t>
+                      </a:r>
+                    </a:p>
+                  </a:txBody>
+                  <a:tcPr>
+                    <a:solidFill>
+                      <a:srgbClr val="FFFFFF"/>
+                    </a:solidFill>
+                  </a:tcPr>
+                </a:tc>
+                <a:tc>
+                  <a:txBody>
+                    <a:bodyPr/>
+                    <a:lstStyle/>
+                    <a:p>
+                      <a:pPr algn="ctr"/>
+                      <a:r>
+                        <a:rPr sz="950" b="1">
+                          <a:solidFill>
+                            <a:srgbClr val="186A3B"/>
+                          </a:solidFill>
+                          <a:latin typeface="Calibri"/>
+                        </a:rPr>
+                        <a:t>Reflect</a:t>
+                      </a:r>
+                    </a:p>
+                  </a:txBody>
+                  <a:tcPr>
+                    <a:solidFill>
+                      <a:srgbClr val="FFFFFF"/>
+                    </a:solidFill>
+                  </a:tcPr>
+                </a:tc>
+                <a:tc>
+                  <a:txBody>
+                    <a:bodyPr/>
+                    <a:lstStyle/>
+                    <a:p>
+                      <a:pPr algn="l"/>
+                      <a:r>
+                        <a:rPr sz="900" b="0">
+                          <a:solidFill>
+                            <a:srgbClr val="2C3E50"/>
+                          </a:solidFill>
+                          <a:latin typeface="Calibri"/>
+                        </a:rPr>
+                        <a:t>Maintains natural leaf texture continuity at image borders after geometric transforms.</a:t>
+                      </a:r>
+                    </a:p>
+                  </a:txBody>
+                  <a:tcPr>
+                    <a:solidFill>
+                      <a:srgbClr val="FFFFFF"/>
+                    </a:solidFill>
+                  </a:tcPr>
+                </a:tc>
+              </a:tr>
+            </a:tbl>
+          </a:graphicData>
+        </a:graphic>
+      </p:graphicFrame>
     </p:spTree>
     <p:extLst>
       <p:ext uri="{BB962C8B-B14F-4D97-AF65-F5344CB8AC3E}">

</xml_diff>